<commit_message>
Replace incorrect pennies-a-day label with temporal reframing throughout
Pennies-a-day (Gourville, 1998) is a related but distinct concept from a
different cited paper -- the actual manipulation and reference study
(Shu, Thomas and Smith, 2021) is termed temporal reframing. Fixed in:
- projects/test-run-1 and test-run-1-n400 design docs and analysis summaries
- presentations/2026-workshop slides.md and workbook.md, with slides.pptx
  and workbook.pdf regenerated to match
</commit_message>
<xml_diff>
--- a/presentations/2026-workshop/slides.pptx
+++ b/presentations/2026-workshop/slides.pptx
@@ -3923,7 +3923,7 @@
             </a:pPr>
             <a:r>
               <a:rPr/>
-              <a:t>The design: pennies-a-day framing</a:t>
+              <a:t>The design: temporal reframing</a:t>
             </a:r>
           </a:p>
         </p:txBody>
@@ -4385,7 +4385,7 @@
             <a:pPr lvl="0"/>
             <a:r>
               <a:rPr/>
-              <a:t>Case study: a “pennies-a-day” savings framing experiment, run twice (N=20, then N=400) and checked against a real published study</a:t>
+              <a:t>Case study: a temporal reframing savings experiment, run twice (N=20, then N=400) and checked against a real published study</a:t>
             </a:r>
           </a:p>
         </p:txBody>

</xml_diff>

<commit_message>
Apply footer/page-number branding pass to slides.pptx
Adapted from a reference course deck the user shared: bottom-left
copyright footer, bottom-right bold navy page number, applied uniformly
across all 30 slides via assets/apply_branding.py (python-pptx
post-processing on the pandoc-generated pptx).

Deliberately does not attempt to reproduce the reference deck institutional
logo bar (Cornell/Dyson/CALS) -- fabricating a university seal or wordmark
from scratch would be an inaccurate imitation of official branding rather
than a real asset. User can add real logo files later, or supply them for
a follow-up pass.
</commit_message>
<xml_diff>
--- a/presentations/2026-workshop/slides.pptx
+++ b/presentations/2026-workshop/slides.pptx
@@ -3210,6 +3210,74 @@
           </a:p>
         </p:txBody>
       </p:sp>
+      <p:sp>
+        <p:nvSpPr>
+          <p:cNvPr id="5" name="TextBox 4"/>
+          <p:cNvSpPr txBox="1"/>
+          <p:nvPr/>
+        </p:nvSpPr>
+        <p:spPr>
+          <a:xfrm>
+            <a:off x="274320" y="4777740"/>
+            <a:ext cx="5486400" cy="274320"/>
+          </a:xfrm>
+          <a:prstGeom prst="rect">
+            <a:avLst/>
+          </a:prstGeom>
+          <a:noFill/>
+        </p:spPr>
+        <p:txBody>
+          <a:bodyPr wrap="none" tIns="0" bIns="0">
+            <a:spAutoFit/>
+          </a:bodyPr>
+          <a:lstStyle/>
+          <a:p>
+            <a:pPr algn="l"/>
+            <a:r>
+              <a:rPr sz="900">
+                <a:solidFill>
+                  <a:srgbClr val="595959"/>
+                </a:solidFill>
+              </a:rPr>
+              <a:t>Copyright © 2026 Behavioral Research Workshop</a:t>
+            </a:r>
+          </a:p>
+        </p:txBody>
+      </p:sp>
+      <p:sp>
+        <p:nvSpPr>
+          <p:cNvPr id="6" name="TextBox 5"/>
+          <p:cNvSpPr txBox="1"/>
+          <p:nvPr/>
+        </p:nvSpPr>
+        <p:spPr>
+          <a:xfrm>
+            <a:off x="8321040" y="4732020"/>
+            <a:ext cx="548640" cy="320040"/>
+          </a:xfrm>
+          <a:prstGeom prst="rect">
+            <a:avLst/>
+          </a:prstGeom>
+          <a:noFill/>
+        </p:spPr>
+        <p:txBody>
+          <a:bodyPr wrap="none" tIns="0" bIns="0">
+            <a:spAutoFit/>
+          </a:bodyPr>
+          <a:lstStyle/>
+          <a:p>
+            <a:pPr algn="r"/>
+            <a:r>
+              <a:rPr sz="1200" b="1">
+                <a:solidFill>
+                  <a:srgbClr val="1F4E79"/>
+                </a:solidFill>
+              </a:rPr>
+              <a:t>1</a:t>
+            </a:r>
+          </a:p>
+        </p:txBody>
+      </p:sp>
     </p:spTree>
   </p:cSld>
 </p:sld>
@@ -3287,6 +3355,74 @@
           </a:ln>
         </p:spPr>
       </p:pic>
+      <p:sp>
+        <p:nvSpPr>
+          <p:cNvPr id="3" name="TextBox 2"/>
+          <p:cNvSpPr txBox="1"/>
+          <p:nvPr/>
+        </p:nvSpPr>
+        <p:spPr>
+          <a:xfrm>
+            <a:off x="274320" y="4777740"/>
+            <a:ext cx="5486400" cy="274320"/>
+          </a:xfrm>
+          <a:prstGeom prst="rect">
+            <a:avLst/>
+          </a:prstGeom>
+          <a:noFill/>
+        </p:spPr>
+        <p:txBody>
+          <a:bodyPr wrap="none" tIns="0" bIns="0">
+            <a:spAutoFit/>
+          </a:bodyPr>
+          <a:lstStyle/>
+          <a:p>
+            <a:pPr algn="l"/>
+            <a:r>
+              <a:rPr sz="900">
+                <a:solidFill>
+                  <a:srgbClr val="595959"/>
+                </a:solidFill>
+              </a:rPr>
+              <a:t>Copyright © 2026 Behavioral Research Workshop</a:t>
+            </a:r>
+          </a:p>
+        </p:txBody>
+      </p:sp>
+      <p:sp>
+        <p:nvSpPr>
+          <p:cNvPr id="4" name="TextBox 3"/>
+          <p:cNvSpPr txBox="1"/>
+          <p:nvPr/>
+        </p:nvSpPr>
+        <p:spPr>
+          <a:xfrm>
+            <a:off x="8321040" y="4732020"/>
+            <a:ext cx="548640" cy="320040"/>
+          </a:xfrm>
+          <a:prstGeom prst="rect">
+            <a:avLst/>
+          </a:prstGeom>
+          <a:noFill/>
+        </p:spPr>
+        <p:txBody>
+          <a:bodyPr wrap="none" tIns="0" bIns="0">
+            <a:spAutoFit/>
+          </a:bodyPr>
+          <a:lstStyle/>
+          <a:p>
+            <a:pPr algn="r"/>
+            <a:r>
+              <a:rPr sz="1200" b="1">
+                <a:solidFill>
+                  <a:srgbClr val="1F4E79"/>
+                </a:solidFill>
+              </a:rPr>
+              <a:t>10</a:t>
+            </a:r>
+          </a:p>
+        </p:txBody>
+      </p:sp>
     </p:spTree>
   </p:cSld>
 </p:sld>
@@ -3390,6 +3526,74 @@
           </a:p>
         </p:txBody>
       </p:sp>
+      <p:sp>
+        <p:nvSpPr>
+          <p:cNvPr id="4" name="TextBox 3"/>
+          <p:cNvSpPr txBox="1"/>
+          <p:nvPr/>
+        </p:nvSpPr>
+        <p:spPr>
+          <a:xfrm>
+            <a:off x="274320" y="4777740"/>
+            <a:ext cx="5486400" cy="274320"/>
+          </a:xfrm>
+          <a:prstGeom prst="rect">
+            <a:avLst/>
+          </a:prstGeom>
+          <a:noFill/>
+        </p:spPr>
+        <p:txBody>
+          <a:bodyPr wrap="none" tIns="0" bIns="0">
+            <a:spAutoFit/>
+          </a:bodyPr>
+          <a:lstStyle/>
+          <a:p>
+            <a:pPr algn="l"/>
+            <a:r>
+              <a:rPr sz="900">
+                <a:solidFill>
+                  <a:srgbClr val="595959"/>
+                </a:solidFill>
+              </a:rPr>
+              <a:t>Copyright © 2026 Behavioral Research Workshop</a:t>
+            </a:r>
+          </a:p>
+        </p:txBody>
+      </p:sp>
+      <p:sp>
+        <p:nvSpPr>
+          <p:cNvPr id="5" name="TextBox 4"/>
+          <p:cNvSpPr txBox="1"/>
+          <p:nvPr/>
+        </p:nvSpPr>
+        <p:spPr>
+          <a:xfrm>
+            <a:off x="8321040" y="4732020"/>
+            <a:ext cx="548640" cy="320040"/>
+          </a:xfrm>
+          <a:prstGeom prst="rect">
+            <a:avLst/>
+          </a:prstGeom>
+          <a:noFill/>
+        </p:spPr>
+        <p:txBody>
+          <a:bodyPr wrap="none" tIns="0" bIns="0">
+            <a:spAutoFit/>
+          </a:bodyPr>
+          <a:lstStyle/>
+          <a:p>
+            <a:pPr algn="r"/>
+            <a:r>
+              <a:rPr sz="1200" b="1">
+                <a:solidFill>
+                  <a:srgbClr val="1F4E79"/>
+                </a:solidFill>
+              </a:rPr>
+              <a:t>11</a:t>
+            </a:r>
+          </a:p>
+        </p:txBody>
+      </p:sp>
     </p:spTree>
   </p:cSld>
 </p:sld>
@@ -3507,6 +3711,74 @@
           </a:p>
         </p:txBody>
       </p:sp>
+      <p:sp>
+        <p:nvSpPr>
+          <p:cNvPr id="4" name="TextBox 3"/>
+          <p:cNvSpPr txBox="1"/>
+          <p:nvPr/>
+        </p:nvSpPr>
+        <p:spPr>
+          <a:xfrm>
+            <a:off x="274320" y="4777740"/>
+            <a:ext cx="5486400" cy="274320"/>
+          </a:xfrm>
+          <a:prstGeom prst="rect">
+            <a:avLst/>
+          </a:prstGeom>
+          <a:noFill/>
+        </p:spPr>
+        <p:txBody>
+          <a:bodyPr wrap="none" tIns="0" bIns="0">
+            <a:spAutoFit/>
+          </a:bodyPr>
+          <a:lstStyle/>
+          <a:p>
+            <a:pPr algn="l"/>
+            <a:r>
+              <a:rPr sz="900">
+                <a:solidFill>
+                  <a:srgbClr val="595959"/>
+                </a:solidFill>
+              </a:rPr>
+              <a:t>Copyright © 2026 Behavioral Research Workshop</a:t>
+            </a:r>
+          </a:p>
+        </p:txBody>
+      </p:sp>
+      <p:sp>
+        <p:nvSpPr>
+          <p:cNvPr id="5" name="TextBox 4"/>
+          <p:cNvSpPr txBox="1"/>
+          <p:nvPr/>
+        </p:nvSpPr>
+        <p:spPr>
+          <a:xfrm>
+            <a:off x="8321040" y="4732020"/>
+            <a:ext cx="548640" cy="320040"/>
+          </a:xfrm>
+          <a:prstGeom prst="rect">
+            <a:avLst/>
+          </a:prstGeom>
+          <a:noFill/>
+        </p:spPr>
+        <p:txBody>
+          <a:bodyPr wrap="none" tIns="0" bIns="0">
+            <a:spAutoFit/>
+          </a:bodyPr>
+          <a:lstStyle/>
+          <a:p>
+            <a:pPr algn="r"/>
+            <a:r>
+              <a:rPr sz="1200" b="1">
+                <a:solidFill>
+                  <a:srgbClr val="1F4E79"/>
+                </a:solidFill>
+              </a:rPr>
+              <a:t>12</a:t>
+            </a:r>
+          </a:p>
+        </p:txBody>
+      </p:sp>
     </p:spTree>
   </p:cSld>
 </p:sld>
@@ -3649,6 +3921,74 @@
           </a:p>
         </p:txBody>
       </p:sp>
+      <p:sp>
+        <p:nvSpPr>
+          <p:cNvPr id="4" name="TextBox 3"/>
+          <p:cNvSpPr txBox="1"/>
+          <p:nvPr/>
+        </p:nvSpPr>
+        <p:spPr>
+          <a:xfrm>
+            <a:off x="274320" y="4777740"/>
+            <a:ext cx="5486400" cy="274320"/>
+          </a:xfrm>
+          <a:prstGeom prst="rect">
+            <a:avLst/>
+          </a:prstGeom>
+          <a:noFill/>
+        </p:spPr>
+        <p:txBody>
+          <a:bodyPr wrap="none" tIns="0" bIns="0">
+            <a:spAutoFit/>
+          </a:bodyPr>
+          <a:lstStyle/>
+          <a:p>
+            <a:pPr algn="l"/>
+            <a:r>
+              <a:rPr sz="900">
+                <a:solidFill>
+                  <a:srgbClr val="595959"/>
+                </a:solidFill>
+              </a:rPr>
+              <a:t>Copyright © 2026 Behavioral Research Workshop</a:t>
+            </a:r>
+          </a:p>
+        </p:txBody>
+      </p:sp>
+      <p:sp>
+        <p:nvSpPr>
+          <p:cNvPr id="5" name="TextBox 4"/>
+          <p:cNvSpPr txBox="1"/>
+          <p:nvPr/>
+        </p:nvSpPr>
+        <p:spPr>
+          <a:xfrm>
+            <a:off x="8321040" y="4732020"/>
+            <a:ext cx="548640" cy="320040"/>
+          </a:xfrm>
+          <a:prstGeom prst="rect">
+            <a:avLst/>
+          </a:prstGeom>
+          <a:noFill/>
+        </p:spPr>
+        <p:txBody>
+          <a:bodyPr wrap="none" tIns="0" bIns="0">
+            <a:spAutoFit/>
+          </a:bodyPr>
+          <a:lstStyle/>
+          <a:p>
+            <a:pPr algn="r"/>
+            <a:r>
+              <a:rPr sz="1200" b="1">
+                <a:solidFill>
+                  <a:srgbClr val="1F4E79"/>
+                </a:solidFill>
+              </a:rPr>
+              <a:t>13</a:t>
+            </a:r>
+          </a:p>
+        </p:txBody>
+      </p:sp>
     </p:spTree>
   </p:cSld>
 </p:sld>
@@ -3758,6 +4098,74 @@
           </a:p>
         </p:txBody>
       </p:sp>
+      <p:sp>
+        <p:nvSpPr>
+          <p:cNvPr id="3" name="TextBox 2"/>
+          <p:cNvSpPr txBox="1"/>
+          <p:nvPr/>
+        </p:nvSpPr>
+        <p:spPr>
+          <a:xfrm>
+            <a:off x="274320" y="4777740"/>
+            <a:ext cx="5486400" cy="274320"/>
+          </a:xfrm>
+          <a:prstGeom prst="rect">
+            <a:avLst/>
+          </a:prstGeom>
+          <a:noFill/>
+        </p:spPr>
+        <p:txBody>
+          <a:bodyPr wrap="none" tIns="0" bIns="0">
+            <a:spAutoFit/>
+          </a:bodyPr>
+          <a:lstStyle/>
+          <a:p>
+            <a:pPr algn="l"/>
+            <a:r>
+              <a:rPr sz="900">
+                <a:solidFill>
+                  <a:srgbClr val="595959"/>
+                </a:solidFill>
+              </a:rPr>
+              <a:t>Copyright © 2026 Behavioral Research Workshop</a:t>
+            </a:r>
+          </a:p>
+        </p:txBody>
+      </p:sp>
+      <p:sp>
+        <p:nvSpPr>
+          <p:cNvPr id="4" name="TextBox 3"/>
+          <p:cNvSpPr txBox="1"/>
+          <p:nvPr/>
+        </p:nvSpPr>
+        <p:spPr>
+          <a:xfrm>
+            <a:off x="8321040" y="4732020"/>
+            <a:ext cx="548640" cy="320040"/>
+          </a:xfrm>
+          <a:prstGeom prst="rect">
+            <a:avLst/>
+          </a:prstGeom>
+          <a:noFill/>
+        </p:spPr>
+        <p:txBody>
+          <a:bodyPr wrap="none" tIns="0" bIns="0">
+            <a:spAutoFit/>
+          </a:bodyPr>
+          <a:lstStyle/>
+          <a:p>
+            <a:pPr algn="r"/>
+            <a:r>
+              <a:rPr sz="1200" b="1">
+                <a:solidFill>
+                  <a:srgbClr val="1F4E79"/>
+                </a:solidFill>
+              </a:rPr>
+              <a:t>14</a:t>
+            </a:r>
+          </a:p>
+        </p:txBody>
+      </p:sp>
     </p:spTree>
   </p:cSld>
 </p:sld>
@@ -3897,6 +4305,74 @@
           </a:p>
         </p:txBody>
       </p:sp>
+      <p:sp>
+        <p:nvSpPr>
+          <p:cNvPr id="4" name="TextBox 3"/>
+          <p:cNvSpPr txBox="1"/>
+          <p:nvPr/>
+        </p:nvSpPr>
+        <p:spPr>
+          <a:xfrm>
+            <a:off x="274320" y="4777740"/>
+            <a:ext cx="5486400" cy="274320"/>
+          </a:xfrm>
+          <a:prstGeom prst="rect">
+            <a:avLst/>
+          </a:prstGeom>
+          <a:noFill/>
+        </p:spPr>
+        <p:txBody>
+          <a:bodyPr wrap="none" tIns="0" bIns="0">
+            <a:spAutoFit/>
+          </a:bodyPr>
+          <a:lstStyle/>
+          <a:p>
+            <a:pPr algn="l"/>
+            <a:r>
+              <a:rPr sz="900">
+                <a:solidFill>
+                  <a:srgbClr val="595959"/>
+                </a:solidFill>
+              </a:rPr>
+              <a:t>Copyright © 2026 Behavioral Research Workshop</a:t>
+            </a:r>
+          </a:p>
+        </p:txBody>
+      </p:sp>
+      <p:sp>
+        <p:nvSpPr>
+          <p:cNvPr id="5" name="TextBox 4"/>
+          <p:cNvSpPr txBox="1"/>
+          <p:nvPr/>
+        </p:nvSpPr>
+        <p:spPr>
+          <a:xfrm>
+            <a:off x="8321040" y="4732020"/>
+            <a:ext cx="548640" cy="320040"/>
+          </a:xfrm>
+          <a:prstGeom prst="rect">
+            <a:avLst/>
+          </a:prstGeom>
+          <a:noFill/>
+        </p:spPr>
+        <p:txBody>
+          <a:bodyPr wrap="none" tIns="0" bIns="0">
+            <a:spAutoFit/>
+          </a:bodyPr>
+          <a:lstStyle/>
+          <a:p>
+            <a:pPr algn="r"/>
+            <a:r>
+              <a:rPr sz="1200" b="1">
+                <a:solidFill>
+                  <a:srgbClr val="1F4E79"/>
+                </a:solidFill>
+              </a:rPr>
+              <a:t>15</a:t>
+            </a:r>
+          </a:p>
+        </p:txBody>
+      </p:sp>
     </p:spTree>
   </p:cSld>
 </p:sld>
@@ -4006,6 +4482,74 @@
           </a:p>
         </p:txBody>
       </p:sp>
+      <p:sp>
+        <p:nvSpPr>
+          <p:cNvPr id="3" name="TextBox 2"/>
+          <p:cNvSpPr txBox="1"/>
+          <p:nvPr/>
+        </p:nvSpPr>
+        <p:spPr>
+          <a:xfrm>
+            <a:off x="274320" y="4777740"/>
+            <a:ext cx="5486400" cy="274320"/>
+          </a:xfrm>
+          <a:prstGeom prst="rect">
+            <a:avLst/>
+          </a:prstGeom>
+          <a:noFill/>
+        </p:spPr>
+        <p:txBody>
+          <a:bodyPr wrap="none" tIns="0" bIns="0">
+            <a:spAutoFit/>
+          </a:bodyPr>
+          <a:lstStyle/>
+          <a:p>
+            <a:pPr algn="l"/>
+            <a:r>
+              <a:rPr sz="900">
+                <a:solidFill>
+                  <a:srgbClr val="595959"/>
+                </a:solidFill>
+              </a:rPr>
+              <a:t>Copyright © 2026 Behavioral Research Workshop</a:t>
+            </a:r>
+          </a:p>
+        </p:txBody>
+      </p:sp>
+      <p:sp>
+        <p:nvSpPr>
+          <p:cNvPr id="4" name="TextBox 3"/>
+          <p:cNvSpPr txBox="1"/>
+          <p:nvPr/>
+        </p:nvSpPr>
+        <p:spPr>
+          <a:xfrm>
+            <a:off x="8321040" y="4732020"/>
+            <a:ext cx="548640" cy="320040"/>
+          </a:xfrm>
+          <a:prstGeom prst="rect">
+            <a:avLst/>
+          </a:prstGeom>
+          <a:noFill/>
+        </p:spPr>
+        <p:txBody>
+          <a:bodyPr wrap="none" tIns="0" bIns="0">
+            <a:spAutoFit/>
+          </a:bodyPr>
+          <a:lstStyle/>
+          <a:p>
+            <a:pPr algn="r"/>
+            <a:r>
+              <a:rPr sz="1200" b="1">
+                <a:solidFill>
+                  <a:srgbClr val="1F4E79"/>
+                </a:solidFill>
+              </a:rPr>
+              <a:t>16</a:t>
+            </a:r>
+          </a:p>
+        </p:txBody>
+      </p:sp>
     </p:spTree>
   </p:cSld>
 </p:sld>
@@ -4109,6 +4653,74 @@
           </a:p>
         </p:txBody>
       </p:sp>
+      <p:sp>
+        <p:nvSpPr>
+          <p:cNvPr id="4" name="TextBox 3"/>
+          <p:cNvSpPr txBox="1"/>
+          <p:nvPr/>
+        </p:nvSpPr>
+        <p:spPr>
+          <a:xfrm>
+            <a:off x="274320" y="4777740"/>
+            <a:ext cx="5486400" cy="274320"/>
+          </a:xfrm>
+          <a:prstGeom prst="rect">
+            <a:avLst/>
+          </a:prstGeom>
+          <a:noFill/>
+        </p:spPr>
+        <p:txBody>
+          <a:bodyPr wrap="none" tIns="0" bIns="0">
+            <a:spAutoFit/>
+          </a:bodyPr>
+          <a:lstStyle/>
+          <a:p>
+            <a:pPr algn="l"/>
+            <a:r>
+              <a:rPr sz="900">
+                <a:solidFill>
+                  <a:srgbClr val="595959"/>
+                </a:solidFill>
+              </a:rPr>
+              <a:t>Copyright © 2026 Behavioral Research Workshop</a:t>
+            </a:r>
+          </a:p>
+        </p:txBody>
+      </p:sp>
+      <p:sp>
+        <p:nvSpPr>
+          <p:cNvPr id="5" name="TextBox 4"/>
+          <p:cNvSpPr txBox="1"/>
+          <p:nvPr/>
+        </p:nvSpPr>
+        <p:spPr>
+          <a:xfrm>
+            <a:off x="8321040" y="4732020"/>
+            <a:ext cx="548640" cy="320040"/>
+          </a:xfrm>
+          <a:prstGeom prst="rect">
+            <a:avLst/>
+          </a:prstGeom>
+          <a:noFill/>
+        </p:spPr>
+        <p:txBody>
+          <a:bodyPr wrap="none" tIns="0" bIns="0">
+            <a:spAutoFit/>
+          </a:bodyPr>
+          <a:lstStyle/>
+          <a:p>
+            <a:pPr algn="r"/>
+            <a:r>
+              <a:rPr sz="1200" b="1">
+                <a:solidFill>
+                  <a:srgbClr val="1F4E79"/>
+                </a:solidFill>
+              </a:rPr>
+              <a:t>17</a:t>
+            </a:r>
+          </a:p>
+        </p:txBody>
+      </p:sp>
     </p:spTree>
   </p:cSld>
 </p:sld>
@@ -4227,6 +4839,74 @@
             <a:r>
               <a:rPr/>
               <a:t>: conditions can be tracked under neutral labels (Condition A/B) until the researcher chooses to reveal which is treatment – avoids analyst bias</a:t>
+            </a:r>
+          </a:p>
+        </p:txBody>
+      </p:sp>
+      <p:sp>
+        <p:nvSpPr>
+          <p:cNvPr id="4" name="TextBox 3"/>
+          <p:cNvSpPr txBox="1"/>
+          <p:nvPr/>
+        </p:nvSpPr>
+        <p:spPr>
+          <a:xfrm>
+            <a:off x="274320" y="4777740"/>
+            <a:ext cx="5486400" cy="274320"/>
+          </a:xfrm>
+          <a:prstGeom prst="rect">
+            <a:avLst/>
+          </a:prstGeom>
+          <a:noFill/>
+        </p:spPr>
+        <p:txBody>
+          <a:bodyPr wrap="none" tIns="0" bIns="0">
+            <a:spAutoFit/>
+          </a:bodyPr>
+          <a:lstStyle/>
+          <a:p>
+            <a:pPr algn="l"/>
+            <a:r>
+              <a:rPr sz="900">
+                <a:solidFill>
+                  <a:srgbClr val="595959"/>
+                </a:solidFill>
+              </a:rPr>
+              <a:t>Copyright © 2026 Behavioral Research Workshop</a:t>
+            </a:r>
+          </a:p>
+        </p:txBody>
+      </p:sp>
+      <p:sp>
+        <p:nvSpPr>
+          <p:cNvPr id="5" name="TextBox 4"/>
+          <p:cNvSpPr txBox="1"/>
+          <p:nvPr/>
+        </p:nvSpPr>
+        <p:spPr>
+          <a:xfrm>
+            <a:off x="8321040" y="4732020"/>
+            <a:ext cx="548640" cy="320040"/>
+          </a:xfrm>
+          <a:prstGeom prst="rect">
+            <a:avLst/>
+          </a:prstGeom>
+          <a:noFill/>
+        </p:spPr>
+        <p:txBody>
+          <a:bodyPr wrap="none" tIns="0" bIns="0">
+            <a:spAutoFit/>
+          </a:bodyPr>
+          <a:lstStyle/>
+          <a:p>
+            <a:pPr algn="r"/>
+            <a:r>
+              <a:rPr sz="1200" b="1">
+                <a:solidFill>
+                  <a:srgbClr val="1F4E79"/>
+                </a:solidFill>
+              </a:rPr>
+              <a:t>18</a:t>
             </a:r>
           </a:p>
         </p:txBody>
@@ -4636,6 +5316,74 @@
           </a:graphicData>
         </a:graphic>
       </p:graphicFrame>
+      <p:sp>
+        <p:nvSpPr>
+          <p:cNvPr id="7" name="TextBox 6"/>
+          <p:cNvSpPr txBox="1"/>
+          <p:nvPr/>
+        </p:nvSpPr>
+        <p:spPr>
+          <a:xfrm>
+            <a:off x="274320" y="4777740"/>
+            <a:ext cx="5486400" cy="274320"/>
+          </a:xfrm>
+          <a:prstGeom prst="rect">
+            <a:avLst/>
+          </a:prstGeom>
+          <a:noFill/>
+        </p:spPr>
+        <p:txBody>
+          <a:bodyPr wrap="none" tIns="0" bIns="0">
+            <a:spAutoFit/>
+          </a:bodyPr>
+          <a:lstStyle/>
+          <a:p>
+            <a:pPr algn="l"/>
+            <a:r>
+              <a:rPr sz="900">
+                <a:solidFill>
+                  <a:srgbClr val="595959"/>
+                </a:solidFill>
+              </a:rPr>
+              <a:t>Copyright © 2026 Behavioral Research Workshop</a:t>
+            </a:r>
+          </a:p>
+        </p:txBody>
+      </p:sp>
+      <p:sp>
+        <p:nvSpPr>
+          <p:cNvPr id="8" name="TextBox 7"/>
+          <p:cNvSpPr txBox="1"/>
+          <p:nvPr/>
+        </p:nvSpPr>
+        <p:spPr>
+          <a:xfrm>
+            <a:off x="8321040" y="4732020"/>
+            <a:ext cx="548640" cy="320040"/>
+          </a:xfrm>
+          <a:prstGeom prst="rect">
+            <a:avLst/>
+          </a:prstGeom>
+          <a:noFill/>
+        </p:spPr>
+        <p:txBody>
+          <a:bodyPr wrap="none" tIns="0" bIns="0">
+            <a:spAutoFit/>
+          </a:bodyPr>
+          <a:lstStyle/>
+          <a:p>
+            <a:pPr algn="r"/>
+            <a:r>
+              <a:rPr sz="1200" b="1">
+                <a:solidFill>
+                  <a:srgbClr val="1F4E79"/>
+                </a:solidFill>
+              </a:rPr>
+              <a:t>19</a:t>
+            </a:r>
+          </a:p>
+        </p:txBody>
+      </p:sp>
     </p:spTree>
   </p:cSld>
 </p:sld>
@@ -4735,6 +5483,74 @@
           </a:p>
         </p:txBody>
       </p:sp>
+      <p:sp>
+        <p:nvSpPr>
+          <p:cNvPr id="4" name="TextBox 3"/>
+          <p:cNvSpPr txBox="1"/>
+          <p:nvPr/>
+        </p:nvSpPr>
+        <p:spPr>
+          <a:xfrm>
+            <a:off x="274320" y="4777740"/>
+            <a:ext cx="5486400" cy="274320"/>
+          </a:xfrm>
+          <a:prstGeom prst="rect">
+            <a:avLst/>
+          </a:prstGeom>
+          <a:noFill/>
+        </p:spPr>
+        <p:txBody>
+          <a:bodyPr wrap="none" tIns="0" bIns="0">
+            <a:spAutoFit/>
+          </a:bodyPr>
+          <a:lstStyle/>
+          <a:p>
+            <a:pPr algn="l"/>
+            <a:r>
+              <a:rPr sz="900">
+                <a:solidFill>
+                  <a:srgbClr val="595959"/>
+                </a:solidFill>
+              </a:rPr>
+              <a:t>Copyright © 2026 Behavioral Research Workshop</a:t>
+            </a:r>
+          </a:p>
+        </p:txBody>
+      </p:sp>
+      <p:sp>
+        <p:nvSpPr>
+          <p:cNvPr id="5" name="TextBox 4"/>
+          <p:cNvSpPr txBox="1"/>
+          <p:nvPr/>
+        </p:nvSpPr>
+        <p:spPr>
+          <a:xfrm>
+            <a:off x="8321040" y="4732020"/>
+            <a:ext cx="548640" cy="320040"/>
+          </a:xfrm>
+          <a:prstGeom prst="rect">
+            <a:avLst/>
+          </a:prstGeom>
+          <a:noFill/>
+        </p:spPr>
+        <p:txBody>
+          <a:bodyPr wrap="none" tIns="0" bIns="0">
+            <a:spAutoFit/>
+          </a:bodyPr>
+          <a:lstStyle/>
+          <a:p>
+            <a:pPr algn="r"/>
+            <a:r>
+              <a:rPr sz="1200" b="1">
+                <a:solidFill>
+                  <a:srgbClr val="1F4E79"/>
+                </a:solidFill>
+              </a:rPr>
+              <a:t>2</a:t>
+            </a:r>
+          </a:p>
+        </p:txBody>
+      </p:sp>
     </p:spTree>
   </p:cSld>
 </p:sld>
@@ -4844,6 +5660,74 @@
           </a:p>
         </p:txBody>
       </p:sp>
+      <p:sp>
+        <p:nvSpPr>
+          <p:cNvPr id="3" name="TextBox 2"/>
+          <p:cNvSpPr txBox="1"/>
+          <p:nvPr/>
+        </p:nvSpPr>
+        <p:spPr>
+          <a:xfrm>
+            <a:off x="274320" y="4777740"/>
+            <a:ext cx="5486400" cy="274320"/>
+          </a:xfrm>
+          <a:prstGeom prst="rect">
+            <a:avLst/>
+          </a:prstGeom>
+          <a:noFill/>
+        </p:spPr>
+        <p:txBody>
+          <a:bodyPr wrap="none" tIns="0" bIns="0">
+            <a:spAutoFit/>
+          </a:bodyPr>
+          <a:lstStyle/>
+          <a:p>
+            <a:pPr algn="l"/>
+            <a:r>
+              <a:rPr sz="900">
+                <a:solidFill>
+                  <a:srgbClr val="595959"/>
+                </a:solidFill>
+              </a:rPr>
+              <a:t>Copyright © 2026 Behavioral Research Workshop</a:t>
+            </a:r>
+          </a:p>
+        </p:txBody>
+      </p:sp>
+      <p:sp>
+        <p:nvSpPr>
+          <p:cNvPr id="4" name="TextBox 3"/>
+          <p:cNvSpPr txBox="1"/>
+          <p:nvPr/>
+        </p:nvSpPr>
+        <p:spPr>
+          <a:xfrm>
+            <a:off x="8321040" y="4732020"/>
+            <a:ext cx="548640" cy="320040"/>
+          </a:xfrm>
+          <a:prstGeom prst="rect">
+            <a:avLst/>
+          </a:prstGeom>
+          <a:noFill/>
+        </p:spPr>
+        <p:txBody>
+          <a:bodyPr wrap="none" tIns="0" bIns="0">
+            <a:spAutoFit/>
+          </a:bodyPr>
+          <a:lstStyle/>
+          <a:p>
+            <a:pPr algn="r"/>
+            <a:r>
+              <a:rPr sz="1200" b="1">
+                <a:solidFill>
+                  <a:srgbClr val="1F4E79"/>
+                </a:solidFill>
+              </a:rPr>
+              <a:t>20</a:t>
+            </a:r>
+          </a:p>
+        </p:txBody>
+      </p:sp>
     </p:spTree>
   </p:cSld>
 </p:sld>
@@ -4951,6 +5835,74 @@
           </a:p>
         </p:txBody>
       </p:sp>
+      <p:sp>
+        <p:nvSpPr>
+          <p:cNvPr id="4" name="TextBox 3"/>
+          <p:cNvSpPr txBox="1"/>
+          <p:nvPr/>
+        </p:nvSpPr>
+        <p:spPr>
+          <a:xfrm>
+            <a:off x="274320" y="4777740"/>
+            <a:ext cx="5486400" cy="274320"/>
+          </a:xfrm>
+          <a:prstGeom prst="rect">
+            <a:avLst/>
+          </a:prstGeom>
+          <a:noFill/>
+        </p:spPr>
+        <p:txBody>
+          <a:bodyPr wrap="none" tIns="0" bIns="0">
+            <a:spAutoFit/>
+          </a:bodyPr>
+          <a:lstStyle/>
+          <a:p>
+            <a:pPr algn="l"/>
+            <a:r>
+              <a:rPr sz="900">
+                <a:solidFill>
+                  <a:srgbClr val="595959"/>
+                </a:solidFill>
+              </a:rPr>
+              <a:t>Copyright © 2026 Behavioral Research Workshop</a:t>
+            </a:r>
+          </a:p>
+        </p:txBody>
+      </p:sp>
+      <p:sp>
+        <p:nvSpPr>
+          <p:cNvPr id="5" name="TextBox 4"/>
+          <p:cNvSpPr txBox="1"/>
+          <p:nvPr/>
+        </p:nvSpPr>
+        <p:spPr>
+          <a:xfrm>
+            <a:off x="8321040" y="4732020"/>
+            <a:ext cx="548640" cy="320040"/>
+          </a:xfrm>
+          <a:prstGeom prst="rect">
+            <a:avLst/>
+          </a:prstGeom>
+          <a:noFill/>
+        </p:spPr>
+        <p:txBody>
+          <a:bodyPr wrap="none" tIns="0" bIns="0">
+            <a:spAutoFit/>
+          </a:bodyPr>
+          <a:lstStyle/>
+          <a:p>
+            <a:pPr algn="r"/>
+            <a:r>
+              <a:rPr sz="1200" b="1">
+                <a:solidFill>
+                  <a:srgbClr val="1F4E79"/>
+                </a:solidFill>
+              </a:rPr>
+              <a:t>21</a:t>
+            </a:r>
+          </a:p>
+        </p:txBody>
+      </p:sp>
     </p:spTree>
   </p:cSld>
 </p:sld>
@@ -5060,6 +6012,74 @@
           </a:p>
         </p:txBody>
       </p:sp>
+      <p:sp>
+        <p:nvSpPr>
+          <p:cNvPr id="3" name="TextBox 2"/>
+          <p:cNvSpPr txBox="1"/>
+          <p:nvPr/>
+        </p:nvSpPr>
+        <p:spPr>
+          <a:xfrm>
+            <a:off x="274320" y="4777740"/>
+            <a:ext cx="5486400" cy="274320"/>
+          </a:xfrm>
+          <a:prstGeom prst="rect">
+            <a:avLst/>
+          </a:prstGeom>
+          <a:noFill/>
+        </p:spPr>
+        <p:txBody>
+          <a:bodyPr wrap="none" tIns="0" bIns="0">
+            <a:spAutoFit/>
+          </a:bodyPr>
+          <a:lstStyle/>
+          <a:p>
+            <a:pPr algn="l"/>
+            <a:r>
+              <a:rPr sz="900">
+                <a:solidFill>
+                  <a:srgbClr val="595959"/>
+                </a:solidFill>
+              </a:rPr>
+              <a:t>Copyright © 2026 Behavioral Research Workshop</a:t>
+            </a:r>
+          </a:p>
+        </p:txBody>
+      </p:sp>
+      <p:sp>
+        <p:nvSpPr>
+          <p:cNvPr id="4" name="TextBox 3"/>
+          <p:cNvSpPr txBox="1"/>
+          <p:nvPr/>
+        </p:nvSpPr>
+        <p:spPr>
+          <a:xfrm>
+            <a:off x="8321040" y="4732020"/>
+            <a:ext cx="548640" cy="320040"/>
+          </a:xfrm>
+          <a:prstGeom prst="rect">
+            <a:avLst/>
+          </a:prstGeom>
+          <a:noFill/>
+        </p:spPr>
+        <p:txBody>
+          <a:bodyPr wrap="none" tIns="0" bIns="0">
+            <a:spAutoFit/>
+          </a:bodyPr>
+          <a:lstStyle/>
+          <a:p>
+            <a:pPr algn="r"/>
+            <a:r>
+              <a:rPr sz="1200" b="1">
+                <a:solidFill>
+                  <a:srgbClr val="1F4E79"/>
+                </a:solidFill>
+              </a:rPr>
+              <a:t>22</a:t>
+            </a:r>
+          </a:p>
+        </p:txBody>
+      </p:sp>
     </p:spTree>
   </p:cSld>
 </p:sld>
@@ -5171,6 +6191,74 @@
           </a:p>
         </p:txBody>
       </p:sp>
+      <p:sp>
+        <p:nvSpPr>
+          <p:cNvPr id="4" name="TextBox 3"/>
+          <p:cNvSpPr txBox="1"/>
+          <p:nvPr/>
+        </p:nvSpPr>
+        <p:spPr>
+          <a:xfrm>
+            <a:off x="274320" y="4777740"/>
+            <a:ext cx="5486400" cy="274320"/>
+          </a:xfrm>
+          <a:prstGeom prst="rect">
+            <a:avLst/>
+          </a:prstGeom>
+          <a:noFill/>
+        </p:spPr>
+        <p:txBody>
+          <a:bodyPr wrap="none" tIns="0" bIns="0">
+            <a:spAutoFit/>
+          </a:bodyPr>
+          <a:lstStyle/>
+          <a:p>
+            <a:pPr algn="l"/>
+            <a:r>
+              <a:rPr sz="900">
+                <a:solidFill>
+                  <a:srgbClr val="595959"/>
+                </a:solidFill>
+              </a:rPr>
+              <a:t>Copyright © 2026 Behavioral Research Workshop</a:t>
+            </a:r>
+          </a:p>
+        </p:txBody>
+      </p:sp>
+      <p:sp>
+        <p:nvSpPr>
+          <p:cNvPr id="5" name="TextBox 4"/>
+          <p:cNvSpPr txBox="1"/>
+          <p:nvPr/>
+        </p:nvSpPr>
+        <p:spPr>
+          <a:xfrm>
+            <a:off x="8321040" y="4732020"/>
+            <a:ext cx="548640" cy="320040"/>
+          </a:xfrm>
+          <a:prstGeom prst="rect">
+            <a:avLst/>
+          </a:prstGeom>
+          <a:noFill/>
+        </p:spPr>
+        <p:txBody>
+          <a:bodyPr wrap="none" tIns="0" bIns="0">
+            <a:spAutoFit/>
+          </a:bodyPr>
+          <a:lstStyle/>
+          <a:p>
+            <a:pPr algn="r"/>
+            <a:r>
+              <a:rPr sz="1200" b="1">
+                <a:solidFill>
+                  <a:srgbClr val="1F4E79"/>
+                </a:solidFill>
+              </a:rPr>
+              <a:t>23</a:t>
+            </a:r>
+          </a:p>
+        </p:txBody>
+      </p:sp>
     </p:spTree>
   </p:cSld>
 </p:sld>
@@ -5290,6 +6378,74 @@
           </a:p>
         </p:txBody>
       </p:sp>
+      <p:sp>
+        <p:nvSpPr>
+          <p:cNvPr id="4" name="TextBox 3"/>
+          <p:cNvSpPr txBox="1"/>
+          <p:nvPr/>
+        </p:nvSpPr>
+        <p:spPr>
+          <a:xfrm>
+            <a:off x="274320" y="4777740"/>
+            <a:ext cx="5486400" cy="274320"/>
+          </a:xfrm>
+          <a:prstGeom prst="rect">
+            <a:avLst/>
+          </a:prstGeom>
+          <a:noFill/>
+        </p:spPr>
+        <p:txBody>
+          <a:bodyPr wrap="none" tIns="0" bIns="0">
+            <a:spAutoFit/>
+          </a:bodyPr>
+          <a:lstStyle/>
+          <a:p>
+            <a:pPr algn="l"/>
+            <a:r>
+              <a:rPr sz="900">
+                <a:solidFill>
+                  <a:srgbClr val="595959"/>
+                </a:solidFill>
+              </a:rPr>
+              <a:t>Copyright © 2026 Behavioral Research Workshop</a:t>
+            </a:r>
+          </a:p>
+        </p:txBody>
+      </p:sp>
+      <p:sp>
+        <p:nvSpPr>
+          <p:cNvPr id="5" name="TextBox 4"/>
+          <p:cNvSpPr txBox="1"/>
+          <p:nvPr/>
+        </p:nvSpPr>
+        <p:spPr>
+          <a:xfrm>
+            <a:off x="8321040" y="4732020"/>
+            <a:ext cx="548640" cy="320040"/>
+          </a:xfrm>
+          <a:prstGeom prst="rect">
+            <a:avLst/>
+          </a:prstGeom>
+          <a:noFill/>
+        </p:spPr>
+        <p:txBody>
+          <a:bodyPr wrap="none" tIns="0" bIns="0">
+            <a:spAutoFit/>
+          </a:bodyPr>
+          <a:lstStyle/>
+          <a:p>
+            <a:pPr algn="r"/>
+            <a:r>
+              <a:rPr sz="1200" b="1">
+                <a:solidFill>
+                  <a:srgbClr val="1F4E79"/>
+                </a:solidFill>
+              </a:rPr>
+              <a:t>24</a:t>
+            </a:r>
+          </a:p>
+        </p:txBody>
+      </p:sp>
     </p:spTree>
   </p:cSld>
 </p:sld>
@@ -5374,6 +6530,74 @@
           </a:p>
         </p:txBody>
       </p:sp>
+      <p:sp>
+        <p:nvSpPr>
+          <p:cNvPr id="4" name="TextBox 3"/>
+          <p:cNvSpPr txBox="1"/>
+          <p:nvPr/>
+        </p:nvSpPr>
+        <p:spPr>
+          <a:xfrm>
+            <a:off x="274320" y="4777740"/>
+            <a:ext cx="5486400" cy="274320"/>
+          </a:xfrm>
+          <a:prstGeom prst="rect">
+            <a:avLst/>
+          </a:prstGeom>
+          <a:noFill/>
+        </p:spPr>
+        <p:txBody>
+          <a:bodyPr wrap="none" tIns="0" bIns="0">
+            <a:spAutoFit/>
+          </a:bodyPr>
+          <a:lstStyle/>
+          <a:p>
+            <a:pPr algn="l"/>
+            <a:r>
+              <a:rPr sz="900">
+                <a:solidFill>
+                  <a:srgbClr val="595959"/>
+                </a:solidFill>
+              </a:rPr>
+              <a:t>Copyright © 2026 Behavioral Research Workshop</a:t>
+            </a:r>
+          </a:p>
+        </p:txBody>
+      </p:sp>
+      <p:sp>
+        <p:nvSpPr>
+          <p:cNvPr id="5" name="TextBox 4"/>
+          <p:cNvSpPr txBox="1"/>
+          <p:nvPr/>
+        </p:nvSpPr>
+        <p:spPr>
+          <a:xfrm>
+            <a:off x="8321040" y="4732020"/>
+            <a:ext cx="548640" cy="320040"/>
+          </a:xfrm>
+          <a:prstGeom prst="rect">
+            <a:avLst/>
+          </a:prstGeom>
+          <a:noFill/>
+        </p:spPr>
+        <p:txBody>
+          <a:bodyPr wrap="none" tIns="0" bIns="0">
+            <a:spAutoFit/>
+          </a:bodyPr>
+          <a:lstStyle/>
+          <a:p>
+            <a:pPr algn="r"/>
+            <a:r>
+              <a:rPr sz="1200" b="1">
+                <a:solidFill>
+                  <a:srgbClr val="1F4E79"/>
+                </a:solidFill>
+              </a:rPr>
+              <a:t>25</a:t>
+            </a:r>
+          </a:p>
+        </p:txBody>
+      </p:sp>
     </p:spTree>
   </p:cSld>
 </p:sld>
@@ -5458,6 +6682,74 @@
           </a:p>
         </p:txBody>
       </p:sp>
+      <p:sp>
+        <p:nvSpPr>
+          <p:cNvPr id="4" name="TextBox 3"/>
+          <p:cNvSpPr txBox="1"/>
+          <p:nvPr/>
+        </p:nvSpPr>
+        <p:spPr>
+          <a:xfrm>
+            <a:off x="274320" y="4777740"/>
+            <a:ext cx="5486400" cy="274320"/>
+          </a:xfrm>
+          <a:prstGeom prst="rect">
+            <a:avLst/>
+          </a:prstGeom>
+          <a:noFill/>
+        </p:spPr>
+        <p:txBody>
+          <a:bodyPr wrap="none" tIns="0" bIns="0">
+            <a:spAutoFit/>
+          </a:bodyPr>
+          <a:lstStyle/>
+          <a:p>
+            <a:pPr algn="l"/>
+            <a:r>
+              <a:rPr sz="900">
+                <a:solidFill>
+                  <a:srgbClr val="595959"/>
+                </a:solidFill>
+              </a:rPr>
+              <a:t>Copyright © 2026 Behavioral Research Workshop</a:t>
+            </a:r>
+          </a:p>
+        </p:txBody>
+      </p:sp>
+      <p:sp>
+        <p:nvSpPr>
+          <p:cNvPr id="5" name="TextBox 4"/>
+          <p:cNvSpPr txBox="1"/>
+          <p:nvPr/>
+        </p:nvSpPr>
+        <p:spPr>
+          <a:xfrm>
+            <a:off x="8321040" y="4732020"/>
+            <a:ext cx="548640" cy="320040"/>
+          </a:xfrm>
+          <a:prstGeom prst="rect">
+            <a:avLst/>
+          </a:prstGeom>
+          <a:noFill/>
+        </p:spPr>
+        <p:txBody>
+          <a:bodyPr wrap="none" tIns="0" bIns="0">
+            <a:spAutoFit/>
+          </a:bodyPr>
+          <a:lstStyle/>
+          <a:p>
+            <a:pPr algn="r"/>
+            <a:r>
+              <a:rPr sz="1200" b="1">
+                <a:solidFill>
+                  <a:srgbClr val="1F4E79"/>
+                </a:solidFill>
+              </a:rPr>
+              <a:t>26</a:t>
+            </a:r>
+          </a:p>
+        </p:txBody>
+      </p:sp>
     </p:spTree>
   </p:cSld>
 </p:sld>
@@ -5577,6 +6869,74 @@
             <a:r>
               <a:rPr/>
               <a:t>Balance check flagged gender as imbalanced (p=.035) – across 6 tests, ~26% chance of at least one false positive; verified main results hold with a gender control</a:t>
+            </a:r>
+          </a:p>
+        </p:txBody>
+      </p:sp>
+      <p:sp>
+        <p:nvSpPr>
+          <p:cNvPr id="4" name="TextBox 3"/>
+          <p:cNvSpPr txBox="1"/>
+          <p:nvPr/>
+        </p:nvSpPr>
+        <p:spPr>
+          <a:xfrm>
+            <a:off x="274320" y="4777740"/>
+            <a:ext cx="5486400" cy="274320"/>
+          </a:xfrm>
+          <a:prstGeom prst="rect">
+            <a:avLst/>
+          </a:prstGeom>
+          <a:noFill/>
+        </p:spPr>
+        <p:txBody>
+          <a:bodyPr wrap="none" tIns="0" bIns="0">
+            <a:spAutoFit/>
+          </a:bodyPr>
+          <a:lstStyle/>
+          <a:p>
+            <a:pPr algn="l"/>
+            <a:r>
+              <a:rPr sz="900">
+                <a:solidFill>
+                  <a:srgbClr val="595959"/>
+                </a:solidFill>
+              </a:rPr>
+              <a:t>Copyright © 2026 Behavioral Research Workshop</a:t>
+            </a:r>
+          </a:p>
+        </p:txBody>
+      </p:sp>
+      <p:sp>
+        <p:nvSpPr>
+          <p:cNvPr id="5" name="TextBox 4"/>
+          <p:cNvSpPr txBox="1"/>
+          <p:nvPr/>
+        </p:nvSpPr>
+        <p:spPr>
+          <a:xfrm>
+            <a:off x="8321040" y="4732020"/>
+            <a:ext cx="548640" cy="320040"/>
+          </a:xfrm>
+          <a:prstGeom prst="rect">
+            <a:avLst/>
+          </a:prstGeom>
+          <a:noFill/>
+        </p:spPr>
+        <p:txBody>
+          <a:bodyPr wrap="none" tIns="0" bIns="0">
+            <a:spAutoFit/>
+          </a:bodyPr>
+          <a:lstStyle/>
+          <a:p>
+            <a:pPr algn="r"/>
+            <a:r>
+              <a:rPr sz="1200" b="1">
+                <a:solidFill>
+                  <a:srgbClr val="1F4E79"/>
+                </a:solidFill>
+              </a:rPr>
+              <a:t>27</a:t>
             </a:r>
           </a:p>
         </p:txBody>
@@ -5898,6 +7258,74 @@
           </a:graphicData>
         </a:graphic>
       </p:graphicFrame>
+      <p:sp>
+        <p:nvSpPr>
+          <p:cNvPr id="7" name="TextBox 6"/>
+          <p:cNvSpPr txBox="1"/>
+          <p:nvPr/>
+        </p:nvSpPr>
+        <p:spPr>
+          <a:xfrm>
+            <a:off x="274320" y="4777740"/>
+            <a:ext cx="5486400" cy="274320"/>
+          </a:xfrm>
+          <a:prstGeom prst="rect">
+            <a:avLst/>
+          </a:prstGeom>
+          <a:noFill/>
+        </p:spPr>
+        <p:txBody>
+          <a:bodyPr wrap="none" tIns="0" bIns="0">
+            <a:spAutoFit/>
+          </a:bodyPr>
+          <a:lstStyle/>
+          <a:p>
+            <a:pPr algn="l"/>
+            <a:r>
+              <a:rPr sz="900">
+                <a:solidFill>
+                  <a:srgbClr val="595959"/>
+                </a:solidFill>
+              </a:rPr>
+              <a:t>Copyright © 2026 Behavioral Research Workshop</a:t>
+            </a:r>
+          </a:p>
+        </p:txBody>
+      </p:sp>
+      <p:sp>
+        <p:nvSpPr>
+          <p:cNvPr id="8" name="TextBox 7"/>
+          <p:cNvSpPr txBox="1"/>
+          <p:nvPr/>
+        </p:nvSpPr>
+        <p:spPr>
+          <a:xfrm>
+            <a:off x="8321040" y="4732020"/>
+            <a:ext cx="548640" cy="320040"/>
+          </a:xfrm>
+          <a:prstGeom prst="rect">
+            <a:avLst/>
+          </a:prstGeom>
+          <a:noFill/>
+        </p:spPr>
+        <p:txBody>
+          <a:bodyPr wrap="none" tIns="0" bIns="0">
+            <a:spAutoFit/>
+          </a:bodyPr>
+          <a:lstStyle/>
+          <a:p>
+            <a:pPr algn="r"/>
+            <a:r>
+              <a:rPr sz="1200" b="1">
+                <a:solidFill>
+                  <a:srgbClr val="1F4E79"/>
+                </a:solidFill>
+              </a:rPr>
+              <a:t>28</a:t>
+            </a:r>
+          </a:p>
+        </p:txBody>
+      </p:sp>
     </p:spTree>
   </p:cSld>
 </p:sld>
@@ -6013,6 +7441,74 @@
           </a:p>
         </p:txBody>
       </p:sp>
+      <p:sp>
+        <p:nvSpPr>
+          <p:cNvPr id="4" name="TextBox 3"/>
+          <p:cNvSpPr txBox="1"/>
+          <p:nvPr/>
+        </p:nvSpPr>
+        <p:spPr>
+          <a:xfrm>
+            <a:off x="274320" y="4777740"/>
+            <a:ext cx="5486400" cy="274320"/>
+          </a:xfrm>
+          <a:prstGeom prst="rect">
+            <a:avLst/>
+          </a:prstGeom>
+          <a:noFill/>
+        </p:spPr>
+        <p:txBody>
+          <a:bodyPr wrap="none" tIns="0" bIns="0">
+            <a:spAutoFit/>
+          </a:bodyPr>
+          <a:lstStyle/>
+          <a:p>
+            <a:pPr algn="l"/>
+            <a:r>
+              <a:rPr sz="900">
+                <a:solidFill>
+                  <a:srgbClr val="595959"/>
+                </a:solidFill>
+              </a:rPr>
+              <a:t>Copyright © 2026 Behavioral Research Workshop</a:t>
+            </a:r>
+          </a:p>
+        </p:txBody>
+      </p:sp>
+      <p:sp>
+        <p:nvSpPr>
+          <p:cNvPr id="5" name="TextBox 4"/>
+          <p:cNvSpPr txBox="1"/>
+          <p:nvPr/>
+        </p:nvSpPr>
+        <p:spPr>
+          <a:xfrm>
+            <a:off x="8321040" y="4732020"/>
+            <a:ext cx="548640" cy="320040"/>
+          </a:xfrm>
+          <a:prstGeom prst="rect">
+            <a:avLst/>
+          </a:prstGeom>
+          <a:noFill/>
+        </p:spPr>
+        <p:txBody>
+          <a:bodyPr wrap="none" tIns="0" bIns="0">
+            <a:spAutoFit/>
+          </a:bodyPr>
+          <a:lstStyle/>
+          <a:p>
+            <a:pPr algn="r"/>
+            <a:r>
+              <a:rPr sz="1200" b="1">
+                <a:solidFill>
+                  <a:srgbClr val="1F4E79"/>
+                </a:solidFill>
+              </a:rPr>
+              <a:t>29</a:t>
+            </a:r>
+          </a:p>
+        </p:txBody>
+      </p:sp>
     </p:spTree>
   </p:cSld>
 </p:sld>
@@ -6090,6 +7586,74 @@
           </a:ln>
         </p:spPr>
       </p:pic>
+      <p:sp>
+        <p:nvSpPr>
+          <p:cNvPr id="3" name="TextBox 2"/>
+          <p:cNvSpPr txBox="1"/>
+          <p:nvPr/>
+        </p:nvSpPr>
+        <p:spPr>
+          <a:xfrm>
+            <a:off x="274320" y="4777740"/>
+            <a:ext cx="5486400" cy="274320"/>
+          </a:xfrm>
+          <a:prstGeom prst="rect">
+            <a:avLst/>
+          </a:prstGeom>
+          <a:noFill/>
+        </p:spPr>
+        <p:txBody>
+          <a:bodyPr wrap="none" tIns="0" bIns="0">
+            <a:spAutoFit/>
+          </a:bodyPr>
+          <a:lstStyle/>
+          <a:p>
+            <a:pPr algn="l"/>
+            <a:r>
+              <a:rPr sz="900">
+                <a:solidFill>
+                  <a:srgbClr val="595959"/>
+                </a:solidFill>
+              </a:rPr>
+              <a:t>Copyright © 2026 Behavioral Research Workshop</a:t>
+            </a:r>
+          </a:p>
+        </p:txBody>
+      </p:sp>
+      <p:sp>
+        <p:nvSpPr>
+          <p:cNvPr id="4" name="TextBox 3"/>
+          <p:cNvSpPr txBox="1"/>
+          <p:nvPr/>
+        </p:nvSpPr>
+        <p:spPr>
+          <a:xfrm>
+            <a:off x="8321040" y="4732020"/>
+            <a:ext cx="548640" cy="320040"/>
+          </a:xfrm>
+          <a:prstGeom prst="rect">
+            <a:avLst/>
+          </a:prstGeom>
+          <a:noFill/>
+        </p:spPr>
+        <p:txBody>
+          <a:bodyPr wrap="none" tIns="0" bIns="0">
+            <a:spAutoFit/>
+          </a:bodyPr>
+          <a:lstStyle/>
+          <a:p>
+            <a:pPr algn="r"/>
+            <a:r>
+              <a:rPr sz="1200" b="1">
+                <a:solidFill>
+                  <a:srgbClr val="1F4E79"/>
+                </a:solidFill>
+              </a:rPr>
+              <a:t>3</a:t>
+            </a:r>
+          </a:p>
+        </p:txBody>
+      </p:sp>
     </p:spTree>
   </p:cSld>
 </p:sld>
@@ -6177,6 +7741,74 @@
           </a:p>
         </p:txBody>
       </p:sp>
+      <p:sp>
+        <p:nvSpPr>
+          <p:cNvPr id="4" name="TextBox 3"/>
+          <p:cNvSpPr txBox="1"/>
+          <p:nvPr/>
+        </p:nvSpPr>
+        <p:spPr>
+          <a:xfrm>
+            <a:off x="274320" y="4777740"/>
+            <a:ext cx="5486400" cy="274320"/>
+          </a:xfrm>
+          <a:prstGeom prst="rect">
+            <a:avLst/>
+          </a:prstGeom>
+          <a:noFill/>
+        </p:spPr>
+        <p:txBody>
+          <a:bodyPr wrap="none" tIns="0" bIns="0">
+            <a:spAutoFit/>
+          </a:bodyPr>
+          <a:lstStyle/>
+          <a:p>
+            <a:pPr algn="l"/>
+            <a:r>
+              <a:rPr sz="900">
+                <a:solidFill>
+                  <a:srgbClr val="595959"/>
+                </a:solidFill>
+              </a:rPr>
+              <a:t>Copyright © 2026 Behavioral Research Workshop</a:t>
+            </a:r>
+          </a:p>
+        </p:txBody>
+      </p:sp>
+      <p:sp>
+        <p:nvSpPr>
+          <p:cNvPr id="5" name="TextBox 4"/>
+          <p:cNvSpPr txBox="1"/>
+          <p:nvPr/>
+        </p:nvSpPr>
+        <p:spPr>
+          <a:xfrm>
+            <a:off x="8321040" y="4732020"/>
+            <a:ext cx="548640" cy="320040"/>
+          </a:xfrm>
+          <a:prstGeom prst="rect">
+            <a:avLst/>
+          </a:prstGeom>
+          <a:noFill/>
+        </p:spPr>
+        <p:txBody>
+          <a:bodyPr wrap="none" tIns="0" bIns="0">
+            <a:spAutoFit/>
+          </a:bodyPr>
+          <a:lstStyle/>
+          <a:p>
+            <a:pPr algn="r"/>
+            <a:r>
+              <a:rPr sz="1200" b="1">
+                <a:solidFill>
+                  <a:srgbClr val="1F4E79"/>
+                </a:solidFill>
+              </a:rPr>
+              <a:t>30</a:t>
+            </a:r>
+          </a:p>
+        </p:txBody>
+      </p:sp>
     </p:spTree>
   </p:cSld>
 </p:sld>
@@ -6306,6 +7938,74 @@
           </a:p>
         </p:txBody>
       </p:sp>
+      <p:sp>
+        <p:nvSpPr>
+          <p:cNvPr id="4" name="TextBox 3"/>
+          <p:cNvSpPr txBox="1"/>
+          <p:nvPr/>
+        </p:nvSpPr>
+        <p:spPr>
+          <a:xfrm>
+            <a:off x="274320" y="4777740"/>
+            <a:ext cx="5486400" cy="274320"/>
+          </a:xfrm>
+          <a:prstGeom prst="rect">
+            <a:avLst/>
+          </a:prstGeom>
+          <a:noFill/>
+        </p:spPr>
+        <p:txBody>
+          <a:bodyPr wrap="none" tIns="0" bIns="0">
+            <a:spAutoFit/>
+          </a:bodyPr>
+          <a:lstStyle/>
+          <a:p>
+            <a:pPr algn="l"/>
+            <a:r>
+              <a:rPr sz="900">
+                <a:solidFill>
+                  <a:srgbClr val="595959"/>
+                </a:solidFill>
+              </a:rPr>
+              <a:t>Copyright © 2026 Behavioral Research Workshop</a:t>
+            </a:r>
+          </a:p>
+        </p:txBody>
+      </p:sp>
+      <p:sp>
+        <p:nvSpPr>
+          <p:cNvPr id="5" name="TextBox 4"/>
+          <p:cNvSpPr txBox="1"/>
+          <p:nvPr/>
+        </p:nvSpPr>
+        <p:spPr>
+          <a:xfrm>
+            <a:off x="8321040" y="4732020"/>
+            <a:ext cx="548640" cy="320040"/>
+          </a:xfrm>
+          <a:prstGeom prst="rect">
+            <a:avLst/>
+          </a:prstGeom>
+          <a:noFill/>
+        </p:spPr>
+        <p:txBody>
+          <a:bodyPr wrap="none" tIns="0" bIns="0">
+            <a:spAutoFit/>
+          </a:bodyPr>
+          <a:lstStyle/>
+          <a:p>
+            <a:pPr algn="r"/>
+            <a:r>
+              <a:rPr sz="1200" b="1">
+                <a:solidFill>
+                  <a:srgbClr val="1F4E79"/>
+                </a:solidFill>
+              </a:rPr>
+              <a:t>4</a:t>
+            </a:r>
+          </a:p>
+        </p:txBody>
+      </p:sp>
     </p:spTree>
   </p:cSld>
 </p:sld>
@@ -6415,6 +8115,74 @@
           </a:p>
         </p:txBody>
       </p:sp>
+      <p:sp>
+        <p:nvSpPr>
+          <p:cNvPr id="3" name="TextBox 2"/>
+          <p:cNvSpPr txBox="1"/>
+          <p:nvPr/>
+        </p:nvSpPr>
+        <p:spPr>
+          <a:xfrm>
+            <a:off x="274320" y="4777740"/>
+            <a:ext cx="5486400" cy="274320"/>
+          </a:xfrm>
+          <a:prstGeom prst="rect">
+            <a:avLst/>
+          </a:prstGeom>
+          <a:noFill/>
+        </p:spPr>
+        <p:txBody>
+          <a:bodyPr wrap="none" tIns="0" bIns="0">
+            <a:spAutoFit/>
+          </a:bodyPr>
+          <a:lstStyle/>
+          <a:p>
+            <a:pPr algn="l"/>
+            <a:r>
+              <a:rPr sz="900">
+                <a:solidFill>
+                  <a:srgbClr val="595959"/>
+                </a:solidFill>
+              </a:rPr>
+              <a:t>Copyright © 2026 Behavioral Research Workshop</a:t>
+            </a:r>
+          </a:p>
+        </p:txBody>
+      </p:sp>
+      <p:sp>
+        <p:nvSpPr>
+          <p:cNvPr id="4" name="TextBox 3"/>
+          <p:cNvSpPr txBox="1"/>
+          <p:nvPr/>
+        </p:nvSpPr>
+        <p:spPr>
+          <a:xfrm>
+            <a:off x="8321040" y="4732020"/>
+            <a:ext cx="548640" cy="320040"/>
+          </a:xfrm>
+          <a:prstGeom prst="rect">
+            <a:avLst/>
+          </a:prstGeom>
+          <a:noFill/>
+        </p:spPr>
+        <p:txBody>
+          <a:bodyPr wrap="none" tIns="0" bIns="0">
+            <a:spAutoFit/>
+          </a:bodyPr>
+          <a:lstStyle/>
+          <a:p>
+            <a:pPr algn="r"/>
+            <a:r>
+              <a:rPr sz="1200" b="1">
+                <a:solidFill>
+                  <a:srgbClr val="1F4E79"/>
+                </a:solidFill>
+              </a:rPr>
+              <a:t>5</a:t>
+            </a:r>
+          </a:p>
+        </p:txBody>
+      </p:sp>
     </p:spTree>
   </p:cSld>
 </p:sld>
@@ -6507,6 +8275,74 @@
           </a:p>
         </p:txBody>
       </p:sp>
+      <p:sp>
+        <p:nvSpPr>
+          <p:cNvPr id="4" name="TextBox 3"/>
+          <p:cNvSpPr txBox="1"/>
+          <p:nvPr/>
+        </p:nvSpPr>
+        <p:spPr>
+          <a:xfrm>
+            <a:off x="274320" y="4777740"/>
+            <a:ext cx="5486400" cy="274320"/>
+          </a:xfrm>
+          <a:prstGeom prst="rect">
+            <a:avLst/>
+          </a:prstGeom>
+          <a:noFill/>
+        </p:spPr>
+        <p:txBody>
+          <a:bodyPr wrap="none" tIns="0" bIns="0">
+            <a:spAutoFit/>
+          </a:bodyPr>
+          <a:lstStyle/>
+          <a:p>
+            <a:pPr algn="l"/>
+            <a:r>
+              <a:rPr sz="900">
+                <a:solidFill>
+                  <a:srgbClr val="595959"/>
+                </a:solidFill>
+              </a:rPr>
+              <a:t>Copyright © 2026 Behavioral Research Workshop</a:t>
+            </a:r>
+          </a:p>
+        </p:txBody>
+      </p:sp>
+      <p:sp>
+        <p:nvSpPr>
+          <p:cNvPr id="5" name="TextBox 4"/>
+          <p:cNvSpPr txBox="1"/>
+          <p:nvPr/>
+        </p:nvSpPr>
+        <p:spPr>
+          <a:xfrm>
+            <a:off x="8321040" y="4732020"/>
+            <a:ext cx="548640" cy="320040"/>
+          </a:xfrm>
+          <a:prstGeom prst="rect">
+            <a:avLst/>
+          </a:prstGeom>
+          <a:noFill/>
+        </p:spPr>
+        <p:txBody>
+          <a:bodyPr wrap="none" tIns="0" bIns="0">
+            <a:spAutoFit/>
+          </a:bodyPr>
+          <a:lstStyle/>
+          <a:p>
+            <a:pPr algn="r"/>
+            <a:r>
+              <a:rPr sz="1200" b="1">
+                <a:solidFill>
+                  <a:srgbClr val="1F4E79"/>
+                </a:solidFill>
+              </a:rPr>
+              <a:t>6</a:t>
+            </a:r>
+          </a:p>
+        </p:txBody>
+      </p:sp>
     </p:spTree>
   </p:cSld>
 </p:sld>
@@ -6633,6 +8469,74 @@
           </a:p>
         </p:txBody>
       </p:sp>
+      <p:sp>
+        <p:nvSpPr>
+          <p:cNvPr id="4" name="TextBox 3"/>
+          <p:cNvSpPr txBox="1"/>
+          <p:nvPr/>
+        </p:nvSpPr>
+        <p:spPr>
+          <a:xfrm>
+            <a:off x="274320" y="4777740"/>
+            <a:ext cx="5486400" cy="274320"/>
+          </a:xfrm>
+          <a:prstGeom prst="rect">
+            <a:avLst/>
+          </a:prstGeom>
+          <a:noFill/>
+        </p:spPr>
+        <p:txBody>
+          <a:bodyPr wrap="none" tIns="0" bIns="0">
+            <a:spAutoFit/>
+          </a:bodyPr>
+          <a:lstStyle/>
+          <a:p>
+            <a:pPr algn="l"/>
+            <a:r>
+              <a:rPr sz="900">
+                <a:solidFill>
+                  <a:srgbClr val="595959"/>
+                </a:solidFill>
+              </a:rPr>
+              <a:t>Copyright © 2026 Behavioral Research Workshop</a:t>
+            </a:r>
+          </a:p>
+        </p:txBody>
+      </p:sp>
+      <p:sp>
+        <p:nvSpPr>
+          <p:cNvPr id="5" name="TextBox 4"/>
+          <p:cNvSpPr txBox="1"/>
+          <p:nvPr/>
+        </p:nvSpPr>
+        <p:spPr>
+          <a:xfrm>
+            <a:off x="8321040" y="4732020"/>
+            <a:ext cx="548640" cy="320040"/>
+          </a:xfrm>
+          <a:prstGeom prst="rect">
+            <a:avLst/>
+          </a:prstGeom>
+          <a:noFill/>
+        </p:spPr>
+        <p:txBody>
+          <a:bodyPr wrap="none" tIns="0" bIns="0">
+            <a:spAutoFit/>
+          </a:bodyPr>
+          <a:lstStyle/>
+          <a:p>
+            <a:pPr algn="r"/>
+            <a:r>
+              <a:rPr sz="1200" b="1">
+                <a:solidFill>
+                  <a:srgbClr val="1F4E79"/>
+                </a:solidFill>
+              </a:rPr>
+              <a:t>7</a:t>
+            </a:r>
+          </a:p>
+        </p:txBody>
+      </p:sp>
     </p:spTree>
   </p:cSld>
 </p:sld>
@@ -6792,6 +8696,74 @@
           </a:p>
         </p:txBody>
       </p:sp>
+      <p:sp>
+        <p:nvSpPr>
+          <p:cNvPr id="4" name="TextBox 3"/>
+          <p:cNvSpPr txBox="1"/>
+          <p:nvPr/>
+        </p:nvSpPr>
+        <p:spPr>
+          <a:xfrm>
+            <a:off x="274320" y="4777740"/>
+            <a:ext cx="5486400" cy="274320"/>
+          </a:xfrm>
+          <a:prstGeom prst="rect">
+            <a:avLst/>
+          </a:prstGeom>
+          <a:noFill/>
+        </p:spPr>
+        <p:txBody>
+          <a:bodyPr wrap="none" tIns="0" bIns="0">
+            <a:spAutoFit/>
+          </a:bodyPr>
+          <a:lstStyle/>
+          <a:p>
+            <a:pPr algn="l"/>
+            <a:r>
+              <a:rPr sz="900">
+                <a:solidFill>
+                  <a:srgbClr val="595959"/>
+                </a:solidFill>
+              </a:rPr>
+              <a:t>Copyright © 2026 Behavioral Research Workshop</a:t>
+            </a:r>
+          </a:p>
+        </p:txBody>
+      </p:sp>
+      <p:sp>
+        <p:nvSpPr>
+          <p:cNvPr id="5" name="TextBox 4"/>
+          <p:cNvSpPr txBox="1"/>
+          <p:nvPr/>
+        </p:nvSpPr>
+        <p:spPr>
+          <a:xfrm>
+            <a:off x="8321040" y="4732020"/>
+            <a:ext cx="548640" cy="320040"/>
+          </a:xfrm>
+          <a:prstGeom prst="rect">
+            <a:avLst/>
+          </a:prstGeom>
+          <a:noFill/>
+        </p:spPr>
+        <p:txBody>
+          <a:bodyPr wrap="none" tIns="0" bIns="0">
+            <a:spAutoFit/>
+          </a:bodyPr>
+          <a:lstStyle/>
+          <a:p>
+            <a:pPr algn="r"/>
+            <a:r>
+              <a:rPr sz="1200" b="1">
+                <a:solidFill>
+                  <a:srgbClr val="1F4E79"/>
+                </a:solidFill>
+              </a:rPr>
+              <a:t>8</a:t>
+            </a:r>
+          </a:p>
+        </p:txBody>
+      </p:sp>
     </p:spTree>
   </p:cSld>
 </p:sld>
@@ -6876,6 +8848,74 @@
       04_synthetic_test/    &lt;- sampled subjects, responses, data
       05_analysis/          &lt;- balance report, regressions, charts
       07_writeup/           &lt;- generated writeup (md + docx)</a:t>
+            </a:r>
+          </a:p>
+        </p:txBody>
+      </p:sp>
+      <p:sp>
+        <p:nvSpPr>
+          <p:cNvPr id="4" name="TextBox 3"/>
+          <p:cNvSpPr txBox="1"/>
+          <p:nvPr/>
+        </p:nvSpPr>
+        <p:spPr>
+          <a:xfrm>
+            <a:off x="274320" y="4777740"/>
+            <a:ext cx="5486400" cy="274320"/>
+          </a:xfrm>
+          <a:prstGeom prst="rect">
+            <a:avLst/>
+          </a:prstGeom>
+          <a:noFill/>
+        </p:spPr>
+        <p:txBody>
+          <a:bodyPr wrap="none" tIns="0" bIns="0">
+            <a:spAutoFit/>
+          </a:bodyPr>
+          <a:lstStyle/>
+          <a:p>
+            <a:pPr algn="l"/>
+            <a:r>
+              <a:rPr sz="900">
+                <a:solidFill>
+                  <a:srgbClr val="595959"/>
+                </a:solidFill>
+              </a:rPr>
+              <a:t>Copyright © 2026 Behavioral Research Workshop</a:t>
+            </a:r>
+          </a:p>
+        </p:txBody>
+      </p:sp>
+      <p:sp>
+        <p:nvSpPr>
+          <p:cNvPr id="5" name="TextBox 4"/>
+          <p:cNvSpPr txBox="1"/>
+          <p:nvPr/>
+        </p:nvSpPr>
+        <p:spPr>
+          <a:xfrm>
+            <a:off x="8321040" y="4732020"/>
+            <a:ext cx="548640" cy="320040"/>
+          </a:xfrm>
+          <a:prstGeom prst="rect">
+            <a:avLst/>
+          </a:prstGeom>
+          <a:noFill/>
+        </p:spPr>
+        <p:txBody>
+          <a:bodyPr wrap="none" tIns="0" bIns="0">
+            <a:spAutoFit/>
+          </a:bodyPr>
+          <a:lstStyle/>
+          <a:p>
+            <a:pPr algn="r"/>
+            <a:r>
+              <a:rPr sz="1200" b="1">
+                <a:solidFill>
+                  <a:srgbClr val="1F4E79"/>
+                </a:solidFill>
+              </a:rPr>
+              <a:t>9</a:t>
             </a:r>
           </a:p>
         </p:txBody>
@@ -7203,265 +9243,4 @@
   </a:objectDefaults>
   <a:extraClrSchemeLst/>
 </a:theme>
-</file>
-
-<file path=ppt/theme/theme2.xml><?xml version="1.0" encoding="utf-8"?>
-<a:theme xmlns:a="http://schemas.openxmlformats.org/drawingml/2006/main" name="Office Theme">
-  <a:themeElements>
-    <a:clrScheme name="Office">
-      <a:dk1>
-        <a:sysClr val="windowText" lastClr="000000"/>
-      </a:dk1>
-      <a:lt1>
-        <a:sysClr val="window" lastClr="FFFFFF"/>
-      </a:lt1>
-      <a:dk2>
-        <a:srgbClr val="44546A"/>
-      </a:dk2>
-      <a:lt2>
-        <a:srgbClr val="E7E6E6"/>
-      </a:lt2>
-      <a:accent1>
-        <a:srgbClr val="5B9BD5"/>
-      </a:accent1>
-      <a:accent2>
-        <a:srgbClr val="ED7D31"/>
-      </a:accent2>
-      <a:accent3>
-        <a:srgbClr val="A5A5A5"/>
-      </a:accent3>
-      <a:accent4>
-        <a:srgbClr val="FFC000"/>
-      </a:accent4>
-      <a:accent5>
-        <a:srgbClr val="4472C4"/>
-      </a:accent5>
-      <a:accent6>
-        <a:srgbClr val="70AD47"/>
-      </a:accent6>
-      <a:hlink>
-        <a:srgbClr val="0563C1"/>
-      </a:hlink>
-      <a:folHlink>
-        <a:srgbClr val="954F72"/>
-      </a:folHlink>
-    </a:clrScheme>
-    <a:fontScheme name="Office">
-      <a:majorFont>
-        <a:latin typeface="Calibri Light" panose="020F0302020204030204"/>
-        <a:ea typeface=""/>
-        <a:cs typeface=""/>
-        <a:font script="Jpan" typeface="ＭＳ Ｐゴシック"/>
-        <a:font script="Hang" typeface="맑은 고딕"/>
-        <a:font script="Hans" typeface="宋体"/>
-        <a:font script="Hant" typeface="新細明體"/>
-        <a:font script="Arab" typeface="Times New Roman"/>
-        <a:font script="Hebr" typeface="Times New Roman"/>
-        <a:font script="Thai" typeface="Angsana New"/>
-        <a:font script="Ethi" typeface="Nyala"/>
-        <a:font script="Beng" typeface="Vrinda"/>
-        <a:font script="Gujr" typeface="Shruti"/>
-        <a:font script="Khmr" typeface="MoolBoran"/>
-        <a:font script="Knda" typeface="Tunga"/>
-        <a:font script="Guru" typeface="Raavi"/>
-        <a:font script="Cans" typeface="Euphemia"/>
-        <a:font script="Cher" typeface="Plantagenet Cherokee"/>
-        <a:font script="Yiii" typeface="Microsoft Yi Baiti"/>
-        <a:font script="Tibt" typeface="Microsoft Himalaya"/>
-        <a:font script="Thaa" typeface="MV Boli"/>
-        <a:font script="Deva" typeface="Mangal"/>
-        <a:font script="Telu" typeface="Gautami"/>
-        <a:font script="Taml" typeface="Latha"/>
-        <a:font script="Syrc" typeface="Estrangelo Edessa"/>
-        <a:font script="Orya" typeface="Kalinga"/>
-        <a:font script="Mlym" typeface="Kartika"/>
-        <a:font script="Laoo" typeface="DokChampa"/>
-        <a:font script="Sinh" typeface="Iskoola Pota"/>
-        <a:font script="Mong" typeface="Mongolian Baiti"/>
-        <a:font script="Viet" typeface="Times New Roman"/>
-        <a:font script="Uigh" typeface="Microsoft Uighur"/>
-        <a:font script="Geor" typeface="Sylfaen"/>
-      </a:majorFont>
-      <a:minorFont>
-        <a:latin typeface="Calibri" panose="020F0502020204030204"/>
-        <a:ea typeface=""/>
-        <a:cs typeface=""/>
-        <a:font script="Jpan" typeface="ＭＳ Ｐゴシック"/>
-        <a:font script="Hang" typeface="맑은 고딕"/>
-        <a:font script="Hans" typeface="宋体"/>
-        <a:font script="Hant" typeface="新細明體"/>
-        <a:font script="Arab" typeface="Arial"/>
-        <a:font script="Hebr" typeface="Arial"/>
-        <a:font script="Thai" typeface="Cordia New"/>
-        <a:font script="Ethi" typeface="Nyala"/>
-        <a:font script="Beng" typeface="Vrinda"/>
-        <a:font script="Gujr" typeface="Shruti"/>
-        <a:font script="Khmr" typeface="DaunPenh"/>
-        <a:font script="Knda" typeface="Tunga"/>
-        <a:font script="Guru" typeface="Raavi"/>
-        <a:font script="Cans" typeface="Euphemia"/>
-        <a:font script="Cher" typeface="Plantagenet Cherokee"/>
-        <a:font script="Yiii" typeface="Microsoft Yi Baiti"/>
-        <a:font script="Tibt" typeface="Microsoft Himalaya"/>
-        <a:font script="Thaa" typeface="MV Boli"/>
-        <a:font script="Deva" typeface="Mangal"/>
-        <a:font script="Telu" typeface="Gautami"/>
-        <a:font script="Taml" typeface="Latha"/>
-        <a:font script="Syrc" typeface="Estrangelo Edessa"/>
-        <a:font script="Orya" typeface="Kalinga"/>
-        <a:font script="Mlym" typeface="Kartika"/>
-        <a:font script="Laoo" typeface="DokChampa"/>
-        <a:font script="Sinh" typeface="Iskoola Pota"/>
-        <a:font script="Mong" typeface="Mongolian Baiti"/>
-        <a:font script="Viet" typeface="Arial"/>
-        <a:font script="Uigh" typeface="Microsoft Uighur"/>
-        <a:font script="Geor" typeface="Sylfaen"/>
-      </a:minorFont>
-    </a:fontScheme>
-    <a:fmtScheme name="Office">
-      <a:fillStyleLst>
-        <a:solidFill>
-          <a:schemeClr val="phClr"/>
-        </a:solidFill>
-        <a:gradFill rotWithShape="1">
-          <a:gsLst>
-            <a:gs pos="0">
-              <a:schemeClr val="phClr">
-                <a:lumMod val="110000"/>
-                <a:satMod val="105000"/>
-                <a:tint val="67000"/>
-              </a:schemeClr>
-            </a:gs>
-            <a:gs pos="50000">
-              <a:schemeClr val="phClr">
-                <a:lumMod val="105000"/>
-                <a:satMod val="103000"/>
-                <a:tint val="73000"/>
-              </a:schemeClr>
-            </a:gs>
-            <a:gs pos="100000">
-              <a:schemeClr val="phClr">
-                <a:lumMod val="105000"/>
-                <a:satMod val="109000"/>
-                <a:tint val="81000"/>
-              </a:schemeClr>
-            </a:gs>
-          </a:gsLst>
-          <a:lin ang="5400000" scaled="0"/>
-        </a:gradFill>
-        <a:gradFill rotWithShape="1">
-          <a:gsLst>
-            <a:gs pos="0">
-              <a:schemeClr val="phClr">
-                <a:satMod val="103000"/>
-                <a:lumMod val="102000"/>
-                <a:tint val="94000"/>
-              </a:schemeClr>
-            </a:gs>
-            <a:gs pos="50000">
-              <a:schemeClr val="phClr">
-                <a:satMod val="110000"/>
-                <a:lumMod val="100000"/>
-                <a:shade val="100000"/>
-              </a:schemeClr>
-            </a:gs>
-            <a:gs pos="100000">
-              <a:schemeClr val="phClr">
-                <a:lumMod val="99000"/>
-                <a:satMod val="120000"/>
-                <a:shade val="78000"/>
-              </a:schemeClr>
-            </a:gs>
-          </a:gsLst>
-          <a:lin ang="5400000" scaled="0"/>
-        </a:gradFill>
-      </a:fillStyleLst>
-      <a:lnStyleLst>
-        <a:ln w="6350" cap="flat" cmpd="sng" algn="ctr">
-          <a:solidFill>
-            <a:schemeClr val="phClr"/>
-          </a:solidFill>
-          <a:prstDash val="solid"/>
-          <a:miter lim="800000"/>
-        </a:ln>
-        <a:ln w="12700" cap="flat" cmpd="sng" algn="ctr">
-          <a:solidFill>
-            <a:schemeClr val="phClr"/>
-          </a:solidFill>
-          <a:prstDash val="solid"/>
-          <a:miter lim="800000"/>
-        </a:ln>
-        <a:ln w="19050" cap="flat" cmpd="sng" algn="ctr">
-          <a:solidFill>
-            <a:schemeClr val="phClr"/>
-          </a:solidFill>
-          <a:prstDash val="solid"/>
-          <a:miter lim="800000"/>
-        </a:ln>
-      </a:lnStyleLst>
-      <a:effectStyleLst>
-        <a:effectStyle>
-          <a:effectLst/>
-        </a:effectStyle>
-        <a:effectStyle>
-          <a:effectLst/>
-        </a:effectStyle>
-        <a:effectStyle>
-          <a:effectLst>
-            <a:outerShdw blurRad="57150" dist="19050" dir="5400000" algn="ctr" rotWithShape="0">
-              <a:srgbClr val="000000">
-                <a:alpha val="63000"/>
-              </a:srgbClr>
-            </a:outerShdw>
-          </a:effectLst>
-        </a:effectStyle>
-      </a:effectStyleLst>
-      <a:bgFillStyleLst>
-        <a:solidFill>
-          <a:schemeClr val="phClr"/>
-        </a:solidFill>
-        <a:solidFill>
-          <a:schemeClr val="phClr">
-            <a:tint val="95000"/>
-            <a:satMod val="170000"/>
-          </a:schemeClr>
-        </a:solidFill>
-        <a:gradFill rotWithShape="1">
-          <a:gsLst>
-            <a:gs pos="0">
-              <a:schemeClr val="phClr">
-                <a:tint val="93000"/>
-                <a:satMod val="150000"/>
-                <a:shade val="98000"/>
-                <a:lumMod val="102000"/>
-              </a:schemeClr>
-            </a:gs>
-            <a:gs pos="50000">
-              <a:schemeClr val="phClr">
-                <a:tint val="98000"/>
-                <a:satMod val="130000"/>
-                <a:shade val="90000"/>
-                <a:lumMod val="103000"/>
-              </a:schemeClr>
-            </a:gs>
-            <a:gs pos="100000">
-              <a:schemeClr val="phClr">
-                <a:shade val="63000"/>
-                <a:satMod val="120000"/>
-              </a:schemeClr>
-            </a:gs>
-          </a:gsLst>
-          <a:lin ang="5400000" scaled="0"/>
-        </a:gradFill>
-      </a:bgFillStyleLst>
-    </a:fmtScheme>
-  </a:themeElements>
-  <a:objectDefaults/>
-  <a:extraClrSchemeLst/>
-  <a:extLst>
-    <a:ext uri="{05A4C25C-085E-4340-85A3-A5531E510DB2}">
-      <thm15:themeFamily xmlns:thm15="http://schemas.microsoft.com/office/thememl/2012/main" name="Office Theme" id="{62F939B6-93AF-4DB8-9C6B-D6C7DFDC589F}" vid="{4A3C46E8-61CC-4603-A589-7422A47A8E4A}"/>
-    </a:ext>
-  </a:extLst>
-</a:theme>
 </file>
</xml_diff>

<commit_message>
Add yellow highlight callout boxes to two punchline slides
Matches the reference deck convention of a bold, bordered yellow box for
a key standalone statement. Applied to the reveal slide (the surprising
match to a real published study) and the takeaways slide (the closing
point that synthetic samples are for iteration, not a substitute for
real data).

Caught and fixed a real python-pptx pitfall along the way: setting only
.height on a placeholder that inherits its size from the slide layout
zeroes out its width, since python-pptx creates a fresh xfrm element
defaulting untouched dimensions to 0. Fixed by capturing left, top, and
width before editing and setting all four dimensions together.
Regenerated slides.pptx from source and reran both post-processing
passes (footer branding, then callouts) to avoid carrying the corrupted
intermediate file forward.
</commit_message>
<xml_diff>
--- a/presentations/2026-workshop/slides.pptx
+++ b/presentations/2026-workshop/slides.pptx
@@ -7003,7 +7003,12 @@
             <p:ph idx="2" sz="half" type="body"/>
           </p:nvPr>
         </p:nvSpPr>
-        <p:spPr/>
+        <p:spPr>
+          <a:xfrm>
+            <a:off x="457201" y="1076326"/>
+            <a:ext cx="3008313" cy="2700000"/>
+          </a:xfrm>
+        </p:spPr>
         <p:txBody>
           <a:bodyPr/>
           <a:lstStyle/>
@@ -7326,6 +7331,59 @@
           </a:p>
         </p:txBody>
       </p:sp>
+      <p:sp>
+        <p:nvSpPr>
+          <p:cNvPr id="9" name="Rounded Rectangle 8"/>
+          <p:cNvSpPr/>
+          <p:nvPr/>
+        </p:nvSpPr>
+        <p:spPr>
+          <a:xfrm>
+            <a:off x="457201" y="3856326"/>
+            <a:ext cx="3008313" cy="750000"/>
+          </a:xfrm>
+          <a:prstGeom prst="roundRect">
+            <a:avLst/>
+          </a:prstGeom>
+          <a:solidFill>
+            <a:srgbClr val="FFFF00"/>
+          </a:solidFill>
+          <a:ln w="19050">
+            <a:solidFill>
+              <a:srgbClr val="000000"/>
+            </a:solidFill>
+          </a:ln>
+        </p:spPr>
+        <p:style>
+          <a:lnRef idx="1">
+            <a:schemeClr val="accent1"/>
+          </a:lnRef>
+          <a:fillRef idx="3">
+            <a:schemeClr val="accent1"/>
+          </a:fillRef>
+          <a:effectRef idx="2">
+            <a:schemeClr val="accent1"/>
+          </a:effectRef>
+          <a:fontRef idx="minor">
+            <a:schemeClr val="lt1"/>
+          </a:fontRef>
+        </p:style>
+        <p:txBody>
+          <a:bodyPr rtlCol="0" anchor="ctr" wrap="square"/>
+          <a:lstStyle/>
+          <a:p>
+            <a:pPr algn="ctr"/>
+            <a:r>
+              <a:rPr sz="1400" b="1">
+                <a:solidFill>
+                  <a:srgbClr val="000000"/>
+                </a:solidFill>
+              </a:rPr>
+              <a:t>We didn't design this to match a published study. It just did.</a:t>
+            </a:r>
+          </a:p>
+        </p:txBody>
+      </p:sp>
     </p:spTree>
   </p:cSld>
 </p:sld>
@@ -7383,7 +7441,12 @@
             <p:ph idx="1"/>
           </p:nvPr>
         </p:nvSpPr>
-        <p:spPr/>
+        <p:spPr>
+          <a:xfrm>
+            <a:off x="457200" y="1200151"/>
+            <a:ext cx="8229600" cy="2700000"/>
+          </a:xfrm>
+        </p:spPr>
         <p:txBody>
           <a:bodyPr/>
           <a:lstStyle/>
@@ -7505,6 +7568,59 @@
                 </a:solidFill>
               </a:rPr>
               <a:t>29</a:t>
+            </a:r>
+          </a:p>
+        </p:txBody>
+      </p:sp>
+      <p:sp>
+        <p:nvSpPr>
+          <p:cNvPr id="6" name="Rounded Rectangle 5"/>
+          <p:cNvSpPr/>
+          <p:nvPr/>
+        </p:nvSpPr>
+        <p:spPr>
+          <a:xfrm>
+            <a:off x="457200" y="3980151"/>
+            <a:ext cx="8229600" cy="650000"/>
+          </a:xfrm>
+          <a:prstGeom prst="roundRect">
+            <a:avLst/>
+          </a:prstGeom>
+          <a:solidFill>
+            <a:srgbClr val="FFFF00"/>
+          </a:solidFill>
+          <a:ln w="19050">
+            <a:solidFill>
+              <a:srgbClr val="000000"/>
+            </a:solidFill>
+          </a:ln>
+        </p:spPr>
+        <p:style>
+          <a:lnRef idx="1">
+            <a:schemeClr val="accent1"/>
+          </a:lnRef>
+          <a:fillRef idx="3">
+            <a:schemeClr val="accent1"/>
+          </a:fillRef>
+          <a:effectRef idx="2">
+            <a:schemeClr val="accent1"/>
+          </a:effectRef>
+          <a:fontRef idx="minor">
+            <a:schemeClr val="lt1"/>
+          </a:fontRef>
+        </p:style>
+        <p:txBody>
+          <a:bodyPr rtlCol="0" anchor="ctr" wrap="square"/>
+          <a:lstStyle/>
+          <a:p>
+            <a:pPr algn="ctr"/>
+            <a:r>
+              <a:rPr sz="1400" b="1">
+                <a:solidFill>
+                  <a:srgbClr val="000000"/>
+                </a:solidFill>
+              </a:rPr>
+              <a:t>Synthetic samples are a tool for iteration — not a substitute for real data.</a:t>
             </a:r>
           </a:p>
         </p:txBody>

</xml_diff>

<commit_message>
Add macOS instructions alongside existing Windows setup steps
The workbook's Section 1 (Prerequisites and Setup) was entirely
Windows/PowerShell-specific: winget installs, .venv\Scripts\ paths,
and $env:Path refresh logic. Added parallel macOS (Homebrew/Terminal)
commands for installing Python, creating a venv, installing git/gh,
and installing pandoc/typst, plus Mac-specific gotchas (Homebrew PATH
setup on Apple Silicon vs Intel, the Xcode Command Line Tools prompt
on first git use). Updated the troubleshooting appendix and command
cheat sheet to match.

Also generalized slide 8 of the deck (the only Windows-specific bullet
in the talk itself) to name both winget and Homebrew rather than
reading as Windows-only.
</commit_message>
<xml_diff>
--- a/presentations/2026-workshop/slides.pptx
+++ b/presentations/2026-workshop/slides.pptx
@@ -8893,14 +8893,12 @@
           <a:p>
             <a:pPr lvl="1"/>
             <a:r>
-              <a:rPr sz="1800">
-                <a:latin typeface="Courier"/>
-              </a:rPr>
-              <a:t>winget install</a:t>
+              <a:rPr b="1" sz="1800"/>
+              <a:t>winget</a:t>
             </a:r>
             <a:r>
               <a:rPr sz="1800"/>
-              <a:t> needed </a:t>
+              <a:t> (Windows) needed </a:t>
             </a:r>
             <a:r>
               <a:rPr sz="1800">
@@ -8910,7 +8908,15 @@
             </a:r>
             <a:r>
               <a:rPr sz="1800"/>
-              <a:t> to dodge an admin-elevation prompt that silently failed in a non-interactive shell</a:t>
+              <a:t> to dodge a silent admin-elevation failure – </a:t>
+            </a:r>
+            <a:r>
+              <a:rPr b="1" sz="1800"/>
+              <a:t>Homebrew</a:t>
+            </a:r>
+            <a:r>
+              <a:rPr sz="1800"/>
+              <a:t> (Mac) has no such prompt</a:t>
             </a:r>
           </a:p>
           <a:p>

</xml_diff>

<commit_message>
Fix slide 9 overflow: normalize Courier to Courier New before measuring
pandoc names code-block/inline-code runs Courier, a font neither
Windows nor macOS actually has installed under that exact name. Each
renderer silently substitutes something different for it, and
LibreOffice happened to pick a narrower substitute than real
PowerPoint does. That made the auto-fit overflow checker (which
renders via LibreOffice to decide what needs shrinking) underestimate
how much vertical space slide 9s code block would take in PowerPoint,
so it passed the check but still overflowed for the user.

fix_overflow.py now renames every Courier run to Courier New -- a
real font on both platforms -- before running the render-shrink loop,
so what gets measured matches what viewers actually see. Regenerated
slides.pptx and re-verified all seven code-block slides (8, 9, 12, 13,
15, 19, 31) render with room to spare.
</commit_message>
<xml_diff>
--- a/presentations/2026-workshop/slides.pptx
+++ b/presentations/2026-workshop/slides.pptx
@@ -3647,7 +3647,7 @@
             </a:r>
             <a:r>
               <a:rPr>
-                <a:latin typeface="Courier"/>
+                <a:latin typeface="Courier New"/>
               </a:rPr>
               <a:t>SKILL.md</a:t>
             </a:r>
@@ -3826,7 +3826,7 @@
             </a:r>
             <a:r>
               <a:rPr sz="1800">
-                <a:latin typeface="Courier"/>
+                <a:latin typeface="Courier New"/>
               </a:rPr>
               <a:t>behavioral-design/SKILL.md</a:t>
             </a:r>
@@ -3836,7 +3836,7 @@
             </a:r>
             <a:r>
               <a:rPr sz="1800">
-                <a:latin typeface="Courier"/>
+                <a:latin typeface="Courier New"/>
               </a:rPr>
               <a:t>name</a:t>
             </a:r>
@@ -3846,7 +3846,7 @@
             </a:r>
             <a:r>
               <a:rPr sz="1800">
-                <a:latin typeface="Courier"/>
+                <a:latin typeface="Courier New"/>
               </a:rPr>
               <a:t>description</a:t>
             </a:r>
@@ -3869,7 +3869,7 @@
             </a:pPr>
             <a:r>
               <a:rPr sz="1800">
-                <a:latin typeface="Courier"/>
+                <a:latin typeface="Courier New"/>
               </a:rPr>
               <a:t>---
 name: behavioral-design
@@ -4213,7 +4213,7 @@
             </a:r>
             <a:r>
               <a:rPr>
-                <a:latin typeface="Courier"/>
+                <a:latin typeface="Courier New"/>
               </a:rPr>
               <a:t>research_design.md</a:t>
             </a:r>
@@ -4223,7 +4223,7 @@
             </a:r>
             <a:r>
               <a:rPr>
-                <a:latin typeface="Courier"/>
+                <a:latin typeface="Courier New"/>
               </a:rPr>
               <a:t>stimuli/*.md</a:t>
             </a:r>
@@ -4233,7 +4233,7 @@
             </a:r>
             <a:r>
               <a:rPr>
-                <a:latin typeface="Courier"/>
+                <a:latin typeface="Courier New"/>
               </a:rPr>
               <a:t>population_spec.md</a:t>
             </a:r>
@@ -4243,7 +4243,7 @@
             </a:r>
             <a:r>
               <a:rPr>
-                <a:latin typeface="Courier"/>
+                <a:latin typeface="Courier New"/>
               </a:rPr>
               <a:t>variables_spec.md</a:t>
             </a:r>
@@ -4959,7 +4959,7 @@
             </a:r>
             <a:r>
               <a:rPr>
-                <a:latin typeface="Courier"/>
+                <a:latin typeface="Courier New"/>
               </a:rPr>
               <a:t>subjects_data.csv</a:t>
             </a:r>
@@ -7966,7 +7966,7 @@
             </a:r>
             <a:r>
               <a:rPr>
-                <a:latin typeface="Courier"/>
+                <a:latin typeface="Courier New"/>
               </a:rPr>
               <a:t>behavioral-research-env</a:t>
             </a:r>
@@ -8849,7 +8849,7 @@
             <a:pPr lvl="0"/>
             <a:r>
               <a:rPr sz="1800">
-                <a:latin typeface="Courier"/>
+                <a:latin typeface="Courier New"/>
               </a:rPr>
               <a:t>python -m venv .venv</a:t>
             </a:r>
@@ -8859,7 +8859,7 @@
             </a:r>
             <a:r>
               <a:rPr sz="1800">
-                <a:latin typeface="Courier"/>
+                <a:latin typeface="Courier New"/>
               </a:rPr>
               <a:t>pip install -r scripts/requirements.txt</a:t>
             </a:r>
@@ -8868,7 +8868,7 @@
             <a:pPr lvl="0"/>
             <a:r>
               <a:rPr sz="1800">
-                <a:latin typeface="Courier"/>
+                <a:latin typeface="Courier New"/>
               </a:rPr>
               <a:t>git init</a:t>
             </a:r>
@@ -8878,7 +8878,7 @@
             </a:r>
             <a:r>
               <a:rPr sz="1800">
-                <a:latin typeface="Courier"/>
+                <a:latin typeface="Courier New"/>
               </a:rPr>
               <a:t>gh repo create --private --source=. --push</a:t>
             </a:r>
@@ -8902,7 +8902,7 @@
             </a:r>
             <a:r>
               <a:rPr sz="1800">
-                <a:latin typeface="Courier"/>
+                <a:latin typeface="Courier New"/>
               </a:rPr>
               <a:t>--scope user</a:t>
             </a:r>
@@ -8934,7 +8934,7 @@
             </a:r>
             <a:r>
               <a:rPr sz="1800">
-                <a:latin typeface="Courier"/>
+                <a:latin typeface="Courier New"/>
               </a:rPr>
               <a:t>--resource-path</a:t>
             </a:r>
@@ -9084,7 +9084,7 @@
             </a:pPr>
             <a:r>
               <a:rPr sz="1600">
-                <a:latin typeface="Courier"/>
+                <a:latin typeface="Courier New"/>
               </a:rPr>
               <a:t>behavioral-research-env/
   .claude/skills/          &lt;- one SKILL.md per workflow stage

</xml_diff>

<commit_message>
Add small note on slide 3 pointing to the Google Antigravity option
Slide 3 (Conceptual Architecture) now carries a one-line caption
noting that a free Google Antigravity stack maps onto the same
architecture shown, with a pointer to workbook Section 7.6 for
details. No paid-tier claim is made beyond what that section already
documents.

Co-Authored-By: Claude Sonnet 5 <noreply@anthropic.com>
</commit_message>
<xml_diff>
--- a/presentations/2026-workshop/slides.pptx
+++ b/presentations/2026-workshop/slides.pptx
@@ -7663,8 +7663,8 @@
         </p:blipFill>
         <p:spPr bwMode="auto">
           <a:xfrm>
-            <a:off x="2082800" y="1193800"/>
-            <a:ext cx="4978400" cy="3390900"/>
+            <a:off x="2463800" y="1193800"/>
+            <a:ext cx="4229100" cy="2882900"/>
           </a:xfrm>
           <a:prstGeom prst="rect">
             <a:avLst/>
@@ -7677,6 +7677,38 @@
           </a:ln>
         </p:spPr>
       </p:pic>
+      <p:sp>
+        <p:nvSpPr>
+          <p:cNvPr id="1" name="TextBox 3"/>
+          <p:cNvSpPr txBox="1"/>
+          <p:nvPr>
+            <p:ph idx="1"/>
+          </p:nvPr>
+        </p:nvSpPr>
+        <p:spPr>
+          <a:xfrm>
+            <a:off x="457200" y="4076700"/>
+            <a:ext cx="8229600" cy="508000"/>
+          </a:xfrm>
+          <a:prstGeom prst="rect">
+            <a:avLst/>
+          </a:prstGeom>
+          <a:noFill/>
+        </p:spPr>
+        <p:txBody>
+          <a:bodyPr/>
+          <a:lstStyle/>
+          <a:p>
+            <a:pPr lvl="0" indent="0" marL="0" algn="ctr">
+              <a:buNone/>
+            </a:pPr>
+            <a:r>
+              <a:rPr sz="1600"/>
+              <a:t>Claude Code shown here – a free Google Antigravity stack maps onto this same architecture, no paid tier required (see workbook Section 7.6).</a:t>
+            </a:r>
+          </a:p>
+        </p:txBody>
+      </p:sp>
       <p:sp>
         <p:nvSpPr>
           <p:cNvPr id="3" name="TextBox 2"/>

</xml_diff>